<commit_message>
Update Entrega final - Proyecto final Grupo 2 - Taller de Programación.pptx
</commit_message>
<xml_diff>
--- a/Proyecto Final/Entrega final - Proyecto final Grupo 2 - Taller de Programación.pptx
+++ b/Proyecto Final/Entrega final - Proyecto final Grupo 2 - Taller de Programación.pptx
@@ -4,13 +4,15 @@
   <p:sldMasterIdLst>
     <p:sldMasterId id="2147483648" r:id="rId1"/>
   </p:sldMasterIdLst>
+  <p:notesMasterIdLst>
+    <p:notesMasterId r:id="rId7"/>
+  </p:notesMasterIdLst>
   <p:sldIdLst>
     <p:sldId id="256" r:id="rId2"/>
-    <p:sldId id="257" r:id="rId3"/>
-    <p:sldId id="258" r:id="rId4"/>
-    <p:sldId id="259" r:id="rId5"/>
-    <p:sldId id="260" r:id="rId6"/>
-    <p:sldId id="261" r:id="rId7"/>
+    <p:sldId id="258" r:id="rId3"/>
+    <p:sldId id="259" r:id="rId4"/>
+    <p:sldId id="260" r:id="rId5"/>
+    <p:sldId id="261" r:id="rId6"/>
   </p:sldIdLst>
   <p:sldSz cx="18288000" cy="10287000"/>
   <p:notesSz cx="6858000" cy="9144000"/>
@@ -20,11 +22,11 @@
       <p:regular r:id="rId8"/>
     </p:embeddedFont>
     <p:embeddedFont>
-      <p:font typeface="Oswald" panose="020F0502020204030204" pitchFamily="2" charset="0"/>
+      <p:font typeface="Oswald" panose="00000500000000000000" pitchFamily="2" charset="0"/>
       <p:regular r:id="rId9"/>
     </p:embeddedFont>
     <p:embeddedFont>
-      <p:font typeface="Oswald Bold" panose="020B0604020202020204" charset="0"/>
+      <p:font typeface="Oswald Bold" panose="00000800000000000000" charset="0"/>
       <p:regular r:id="rId10"/>
     </p:embeddedFont>
   </p:embeddedFontLst>
@@ -142,6 +144,415 @@
 </p:presentation>
 </file>
 
+<file path=ppt/revisionInfo.xml><?xml version="1.0" encoding="utf-8"?>
+<p1510:revInfo xmlns:a="http://schemas.openxmlformats.org/drawingml/2006/main" xmlns:r="http://schemas.openxmlformats.org/officeDocument/2006/relationships" xmlns:p1510="http://schemas.microsoft.com/office/powerpoint/2015/10/main">
+  <p1510:revLst>
+    <p1510:client id="{132DEA35-303A-4C15-9AEB-34A5D0B75E4B}" v="2" dt="2025-12-02T23:24:58.841"/>
+  </p1510:revLst>
+</p1510:revInfo>
+</file>
+
+<file path=ppt/changesInfos/changesInfo1.xml><?xml version="1.0" encoding="utf-8"?>
+<pc:chgInfo xmlns:a="http://schemas.openxmlformats.org/drawingml/2006/main" xmlns:r="http://schemas.openxmlformats.org/officeDocument/2006/relationships" xmlns:ac="http://schemas.microsoft.com/office/drawing/2013/main/command" xmlns:pc="http://schemas.microsoft.com/office/powerpoint/2013/main/command">
+  <pc:docChgLst>
+    <pc:chgData name="Martin Alvarez" userId="10705b4323551338" providerId="LiveId" clId="{132DEA35-303A-4C15-9AEB-34A5D0B75E4B}"/>
+    <pc:docChg chg="undo custSel delSld modSld">
+      <pc:chgData name="Martin Alvarez" userId="10705b4323551338" providerId="LiveId" clId="{132DEA35-303A-4C15-9AEB-34A5D0B75E4B}" dt="2025-12-02T23:21:20.067" v="13" actId="1076"/>
+      <pc:docMkLst>
+        <pc:docMk/>
+      </pc:docMkLst>
+      <pc:sldChg chg="modSp mod">
+        <pc:chgData name="Martin Alvarez" userId="10705b4323551338" providerId="LiveId" clId="{132DEA35-303A-4C15-9AEB-34A5D0B75E4B}" dt="2025-12-02T23:21:20.067" v="13" actId="1076"/>
+        <pc:sldMkLst>
+          <pc:docMk/>
+          <pc:sldMk cId="0" sldId="256"/>
+        </pc:sldMkLst>
+        <pc:grpChg chg="mod">
+          <ac:chgData name="Martin Alvarez" userId="10705b4323551338" providerId="LiveId" clId="{132DEA35-303A-4C15-9AEB-34A5D0B75E4B}" dt="2025-12-02T23:21:20.067" v="13" actId="1076"/>
+          <ac:grpSpMkLst>
+            <pc:docMk/>
+            <pc:sldMk cId="0" sldId="256"/>
+            <ac:grpSpMk id="18" creationId="{00000000-0000-0000-0000-000000000000}"/>
+          </ac:grpSpMkLst>
+        </pc:grpChg>
+      </pc:sldChg>
+      <pc:sldChg chg="del">
+        <pc:chgData name="Martin Alvarez" userId="10705b4323551338" providerId="LiveId" clId="{132DEA35-303A-4C15-9AEB-34A5D0B75E4B}" dt="2025-12-02T23:15:39.301" v="0" actId="47"/>
+        <pc:sldMkLst>
+          <pc:docMk/>
+          <pc:sldMk cId="0" sldId="257"/>
+        </pc:sldMkLst>
+      </pc:sldChg>
+      <pc:sldChg chg="modSp mod">
+        <pc:chgData name="Martin Alvarez" userId="10705b4323551338" providerId="LiveId" clId="{132DEA35-303A-4C15-9AEB-34A5D0B75E4B}" dt="2025-12-02T23:20:46.920" v="11" actId="1076"/>
+        <pc:sldMkLst>
+          <pc:docMk/>
+          <pc:sldMk cId="0" sldId="259"/>
+        </pc:sldMkLst>
+        <pc:spChg chg="mod">
+          <ac:chgData name="Martin Alvarez" userId="10705b4323551338" providerId="LiveId" clId="{132DEA35-303A-4C15-9AEB-34A5D0B75E4B}" dt="2025-12-02T23:20:46.920" v="11" actId="1076"/>
+          <ac:spMkLst>
+            <pc:docMk/>
+            <pc:sldMk cId="0" sldId="259"/>
+            <ac:spMk id="5" creationId="{00000000-0000-0000-0000-000000000000}"/>
+          </ac:spMkLst>
+        </pc:spChg>
+      </pc:sldChg>
+    </pc:docChg>
+  </pc:docChgLst>
+</pc:chgInfo>
+</file>
+
+<file path=ppt/notesMasters/notesMaster1.xml><?xml version="1.0" encoding="utf-8"?>
+<p:notesMaster xmlns:a="http://schemas.openxmlformats.org/drawingml/2006/main" xmlns:r="http://schemas.openxmlformats.org/officeDocument/2006/relationships" xmlns:p="http://schemas.openxmlformats.org/presentationml/2006/main">
+  <p:cSld>
+    <p:bg>
+      <p:bgRef idx="1001">
+        <a:schemeClr val="bg1"/>
+      </p:bgRef>
+    </p:bg>
+    <p:spTree>
+      <p:nvGrpSpPr>
+        <p:cNvPr id="1" name=""/>
+        <p:cNvGrpSpPr/>
+        <p:nvPr/>
+      </p:nvGrpSpPr>
+      <p:grpSpPr>
+        <a:xfrm>
+          <a:off x="0" y="0"/>
+          <a:ext cx="0" cy="0"/>
+          <a:chOff x="0" y="0"/>
+          <a:chExt cx="0" cy="0"/>
+        </a:xfrm>
+      </p:grpSpPr>
+      <p:sp>
+        <p:nvSpPr>
+          <p:cNvPr id="2" name="Marcador de encabezado 1"/>
+          <p:cNvSpPr>
+            <a:spLocks noGrp="1"/>
+          </p:cNvSpPr>
+          <p:nvPr>
+            <p:ph type="hdr" sz="quarter"/>
+          </p:nvPr>
+        </p:nvSpPr>
+        <p:spPr>
+          <a:xfrm>
+            <a:off x="0" y="0"/>
+            <a:ext cx="2971800" cy="458788"/>
+          </a:xfrm>
+          <a:prstGeom prst="rect">
+            <a:avLst/>
+          </a:prstGeom>
+        </p:spPr>
+        <p:txBody>
+          <a:bodyPr vert="horz" lIns="91440" tIns="45720" rIns="91440" bIns="45720" rtlCol="0"/>
+          <a:lstStyle>
+            <a:lvl1pPr algn="l">
+              <a:defRPr sz="1200"/>
+            </a:lvl1pPr>
+          </a:lstStyle>
+          <a:p>
+            <a:endParaRPr lang="es-AR"/>
+          </a:p>
+        </p:txBody>
+      </p:sp>
+      <p:sp>
+        <p:nvSpPr>
+          <p:cNvPr id="3" name="Marcador de fecha 2"/>
+          <p:cNvSpPr>
+            <a:spLocks noGrp="1"/>
+          </p:cNvSpPr>
+          <p:nvPr>
+            <p:ph type="dt" idx="1"/>
+          </p:nvPr>
+        </p:nvSpPr>
+        <p:spPr>
+          <a:xfrm>
+            <a:off x="3884613" y="0"/>
+            <a:ext cx="2971800" cy="458788"/>
+          </a:xfrm>
+          <a:prstGeom prst="rect">
+            <a:avLst/>
+          </a:prstGeom>
+        </p:spPr>
+        <p:txBody>
+          <a:bodyPr vert="horz" lIns="91440" tIns="45720" rIns="91440" bIns="45720" rtlCol="0"/>
+          <a:lstStyle>
+            <a:lvl1pPr algn="r">
+              <a:defRPr sz="1200"/>
+            </a:lvl1pPr>
+          </a:lstStyle>
+          <a:p>
+            <a:fld id="{96AE6B78-C38B-4B5C-9A59-4F2CB90A0972}" type="datetimeFigureOut">
+              <a:rPr lang="es-AR" smtClean="0"/>
+              <a:t>2/12/2025</a:t>
+            </a:fld>
+            <a:endParaRPr lang="es-AR"/>
+          </a:p>
+        </p:txBody>
+      </p:sp>
+      <p:sp>
+        <p:nvSpPr>
+          <p:cNvPr id="4" name="Marcador de imagen de diapositiva 3"/>
+          <p:cNvSpPr>
+            <a:spLocks noGrp="1" noRot="1" noChangeAspect="1"/>
+          </p:cNvSpPr>
+          <p:nvPr>
+            <p:ph type="sldImg" idx="2"/>
+          </p:nvPr>
+        </p:nvSpPr>
+        <p:spPr>
+          <a:xfrm>
+            <a:off x="685800" y="1143000"/>
+            <a:ext cx="5486400" cy="3086100"/>
+          </a:xfrm>
+          <a:prstGeom prst="rect">
+            <a:avLst/>
+          </a:prstGeom>
+          <a:noFill/>
+          <a:ln w="12700">
+            <a:solidFill>
+              <a:prstClr val="black"/>
+            </a:solidFill>
+          </a:ln>
+        </p:spPr>
+        <p:txBody>
+          <a:bodyPr vert="horz" lIns="91440" tIns="45720" rIns="91440" bIns="45720" rtlCol="0" anchor="ctr"/>
+          <a:lstStyle/>
+          <a:p>
+            <a:endParaRPr lang="es-AR"/>
+          </a:p>
+        </p:txBody>
+      </p:sp>
+      <p:sp>
+        <p:nvSpPr>
+          <p:cNvPr id="5" name="Marcador de notas 4"/>
+          <p:cNvSpPr>
+            <a:spLocks noGrp="1"/>
+          </p:cNvSpPr>
+          <p:nvPr>
+            <p:ph type="body" sz="quarter" idx="3"/>
+          </p:nvPr>
+        </p:nvSpPr>
+        <p:spPr>
+          <a:xfrm>
+            <a:off x="685800" y="4400550"/>
+            <a:ext cx="5486400" cy="3600450"/>
+          </a:xfrm>
+          <a:prstGeom prst="rect">
+            <a:avLst/>
+          </a:prstGeom>
+        </p:spPr>
+        <p:txBody>
+          <a:bodyPr vert="horz" lIns="91440" tIns="45720" rIns="91440" bIns="45720" rtlCol="0"/>
+          <a:lstStyle/>
+          <a:p>
+            <a:pPr lvl="0"/>
+            <a:r>
+              <a:rPr lang="es-ES"/>
+              <a:t>Haga clic para modificar los estilos de texto del patrón</a:t>
+            </a:r>
+          </a:p>
+          <a:p>
+            <a:pPr lvl="1"/>
+            <a:r>
+              <a:rPr lang="es-ES"/>
+              <a:t>Segundo nivel</a:t>
+            </a:r>
+          </a:p>
+          <a:p>
+            <a:pPr lvl="2"/>
+            <a:r>
+              <a:rPr lang="es-ES"/>
+              <a:t>Tercer nivel</a:t>
+            </a:r>
+          </a:p>
+          <a:p>
+            <a:pPr lvl="3"/>
+            <a:r>
+              <a:rPr lang="es-ES"/>
+              <a:t>Cuarto nivel</a:t>
+            </a:r>
+          </a:p>
+          <a:p>
+            <a:pPr lvl="4"/>
+            <a:r>
+              <a:rPr lang="es-ES"/>
+              <a:t>Quinto nivel</a:t>
+            </a:r>
+            <a:endParaRPr lang="es-AR"/>
+          </a:p>
+        </p:txBody>
+      </p:sp>
+      <p:sp>
+        <p:nvSpPr>
+          <p:cNvPr id="6" name="Marcador de pie de página 5"/>
+          <p:cNvSpPr>
+            <a:spLocks noGrp="1"/>
+          </p:cNvSpPr>
+          <p:nvPr>
+            <p:ph type="ftr" sz="quarter" idx="4"/>
+          </p:nvPr>
+        </p:nvSpPr>
+        <p:spPr>
+          <a:xfrm>
+            <a:off x="0" y="8685213"/>
+            <a:ext cx="2971800" cy="458787"/>
+          </a:xfrm>
+          <a:prstGeom prst="rect">
+            <a:avLst/>
+          </a:prstGeom>
+        </p:spPr>
+        <p:txBody>
+          <a:bodyPr vert="horz" lIns="91440" tIns="45720" rIns="91440" bIns="45720" rtlCol="0" anchor="b"/>
+          <a:lstStyle>
+            <a:lvl1pPr algn="l">
+              <a:defRPr sz="1200"/>
+            </a:lvl1pPr>
+          </a:lstStyle>
+          <a:p>
+            <a:endParaRPr lang="es-AR"/>
+          </a:p>
+        </p:txBody>
+      </p:sp>
+      <p:sp>
+        <p:nvSpPr>
+          <p:cNvPr id="7" name="Marcador de número de diapositiva 6"/>
+          <p:cNvSpPr>
+            <a:spLocks noGrp="1"/>
+          </p:cNvSpPr>
+          <p:nvPr>
+            <p:ph type="sldNum" sz="quarter" idx="5"/>
+          </p:nvPr>
+        </p:nvSpPr>
+        <p:spPr>
+          <a:xfrm>
+            <a:off x="3884613" y="8685213"/>
+            <a:ext cx="2971800" cy="458787"/>
+          </a:xfrm>
+          <a:prstGeom prst="rect">
+            <a:avLst/>
+          </a:prstGeom>
+        </p:spPr>
+        <p:txBody>
+          <a:bodyPr vert="horz" lIns="91440" tIns="45720" rIns="91440" bIns="45720" rtlCol="0" anchor="b"/>
+          <a:lstStyle>
+            <a:lvl1pPr algn="r">
+              <a:defRPr sz="1200"/>
+            </a:lvl1pPr>
+          </a:lstStyle>
+          <a:p>
+            <a:fld id="{C43209A0-CD1A-4331-85B8-A8CF64E15EE0}" type="slidenum">
+              <a:rPr lang="es-AR" smtClean="0"/>
+              <a:t>‹Nº›</a:t>
+            </a:fld>
+            <a:endParaRPr lang="es-AR"/>
+          </a:p>
+        </p:txBody>
+      </p:sp>
+    </p:spTree>
+    <p:extLst>
+      <p:ext uri="{BB962C8B-B14F-4D97-AF65-F5344CB8AC3E}">
+        <p14:creationId xmlns:p14="http://schemas.microsoft.com/office/powerpoint/2010/main" val="2250660096"/>
+      </p:ext>
+    </p:extLst>
+  </p:cSld>
+  <p:clrMap bg1="lt1" tx1="dk1" bg2="lt2" tx2="dk2" accent1="accent1" accent2="accent2" accent3="accent3" accent4="accent4" accent5="accent5" accent6="accent6" hlink="hlink" folHlink="folHlink"/>
+  <p:notesStyle>
+    <a:lvl1pPr marL="0" algn="l" defTabSz="914400" rtl="0" eaLnBrk="1" latinLnBrk="0" hangingPunct="1">
+      <a:defRPr sz="1200" kern="1200">
+        <a:solidFill>
+          <a:schemeClr val="tx1"/>
+        </a:solidFill>
+        <a:latin typeface="+mn-lt"/>
+        <a:ea typeface="+mn-ea"/>
+        <a:cs typeface="+mn-cs"/>
+      </a:defRPr>
+    </a:lvl1pPr>
+    <a:lvl2pPr marL="457200" algn="l" defTabSz="914400" rtl="0" eaLnBrk="1" latinLnBrk="0" hangingPunct="1">
+      <a:defRPr sz="1200" kern="1200">
+        <a:solidFill>
+          <a:schemeClr val="tx1"/>
+        </a:solidFill>
+        <a:latin typeface="+mn-lt"/>
+        <a:ea typeface="+mn-ea"/>
+        <a:cs typeface="+mn-cs"/>
+      </a:defRPr>
+    </a:lvl2pPr>
+    <a:lvl3pPr marL="914400" algn="l" defTabSz="914400" rtl="0" eaLnBrk="1" latinLnBrk="0" hangingPunct="1">
+      <a:defRPr sz="1200" kern="1200">
+        <a:solidFill>
+          <a:schemeClr val="tx1"/>
+        </a:solidFill>
+        <a:latin typeface="+mn-lt"/>
+        <a:ea typeface="+mn-ea"/>
+        <a:cs typeface="+mn-cs"/>
+      </a:defRPr>
+    </a:lvl3pPr>
+    <a:lvl4pPr marL="1371600" algn="l" defTabSz="914400" rtl="0" eaLnBrk="1" latinLnBrk="0" hangingPunct="1">
+      <a:defRPr sz="1200" kern="1200">
+        <a:solidFill>
+          <a:schemeClr val="tx1"/>
+        </a:solidFill>
+        <a:latin typeface="+mn-lt"/>
+        <a:ea typeface="+mn-ea"/>
+        <a:cs typeface="+mn-cs"/>
+      </a:defRPr>
+    </a:lvl4pPr>
+    <a:lvl5pPr marL="1828800" algn="l" defTabSz="914400" rtl="0" eaLnBrk="1" latinLnBrk="0" hangingPunct="1">
+      <a:defRPr sz="1200" kern="1200">
+        <a:solidFill>
+          <a:schemeClr val="tx1"/>
+        </a:solidFill>
+        <a:latin typeface="+mn-lt"/>
+        <a:ea typeface="+mn-ea"/>
+        <a:cs typeface="+mn-cs"/>
+      </a:defRPr>
+    </a:lvl5pPr>
+    <a:lvl6pPr marL="2286000" algn="l" defTabSz="914400" rtl="0" eaLnBrk="1" latinLnBrk="0" hangingPunct="1">
+      <a:defRPr sz="1200" kern="1200">
+        <a:solidFill>
+          <a:schemeClr val="tx1"/>
+        </a:solidFill>
+        <a:latin typeface="+mn-lt"/>
+        <a:ea typeface="+mn-ea"/>
+        <a:cs typeface="+mn-cs"/>
+      </a:defRPr>
+    </a:lvl6pPr>
+    <a:lvl7pPr marL="2743200" algn="l" defTabSz="914400" rtl="0" eaLnBrk="1" latinLnBrk="0" hangingPunct="1">
+      <a:defRPr sz="1200" kern="1200">
+        <a:solidFill>
+          <a:schemeClr val="tx1"/>
+        </a:solidFill>
+        <a:latin typeface="+mn-lt"/>
+        <a:ea typeface="+mn-ea"/>
+        <a:cs typeface="+mn-cs"/>
+      </a:defRPr>
+    </a:lvl7pPr>
+    <a:lvl8pPr marL="3200400" algn="l" defTabSz="914400" rtl="0" eaLnBrk="1" latinLnBrk="0" hangingPunct="1">
+      <a:defRPr sz="1200" kern="1200">
+        <a:solidFill>
+          <a:schemeClr val="tx1"/>
+        </a:solidFill>
+        <a:latin typeface="+mn-lt"/>
+        <a:ea typeface="+mn-ea"/>
+        <a:cs typeface="+mn-cs"/>
+      </a:defRPr>
+    </a:lvl8pPr>
+    <a:lvl9pPr marL="3657600" algn="l" defTabSz="914400" rtl="0" eaLnBrk="1" latinLnBrk="0" hangingPunct="1">
+      <a:defRPr sz="1200" kern="1200">
+        <a:solidFill>
+          <a:schemeClr val="tx1"/>
+        </a:solidFill>
+        <a:latin typeface="+mn-lt"/>
+        <a:ea typeface="+mn-ea"/>
+        <a:cs typeface="+mn-cs"/>
+      </a:defRPr>
+    </a:lvl9pPr>
+  </p:notesStyle>
+</p:notesMaster>
+</file>
+
 <file path=ppt/slideLayouts/slideLayout1.xml><?xml version="1.0" encoding="utf-8"?>
 <p:sldLayout xmlns:a="http://schemas.openxmlformats.org/drawingml/2006/main" xmlns:r="http://schemas.openxmlformats.org/officeDocument/2006/relationships" xmlns:p="http://schemas.openxmlformats.org/presentationml/2006/main" type="title" preserve="1">
   <p:cSld name="Title Slide">
@@ -319,10 +730,9 @@
           <a:bodyPr/>
           <a:lstStyle/>
           <a:p>
-            <a:fld id="{1D8BD707-D9CF-40AE-B4C6-C98DA3205C09}" type="datetimeFigureOut">
+            <a:fld id="{2A427CD1-653D-4C01-A70A-EBF02967BB01}" type="datetime1">
               <a:rPr lang="en-US" smtClean="0"/>
-              <a:pPr/>
-              <a:t>11/30/2025</a:t>
+              <a:t>12/2/2025</a:t>
             </a:fld>
             <a:endParaRPr lang="en-US"/>
           </a:p>
@@ -484,10 +894,9 @@
           <a:bodyPr/>
           <a:lstStyle/>
           <a:p>
-            <a:fld id="{1D8BD707-D9CF-40AE-B4C6-C98DA3205C09}" type="datetimeFigureOut">
+            <a:fld id="{5A062DD9-77C6-4C51-913D-36C0A901D8E2}" type="datetime1">
               <a:rPr lang="en-US" smtClean="0"/>
-              <a:pPr/>
-              <a:t>11/30/2025</a:t>
+              <a:t>12/2/2025</a:t>
             </a:fld>
             <a:endParaRPr lang="en-US"/>
           </a:p>
@@ -659,10 +1068,9 @@
           <a:bodyPr/>
           <a:lstStyle/>
           <a:p>
-            <a:fld id="{1D8BD707-D9CF-40AE-B4C6-C98DA3205C09}" type="datetimeFigureOut">
+            <a:fld id="{CE16C94D-AE0F-4C46-9C46-222085FAE477}" type="datetime1">
               <a:rPr lang="en-US" smtClean="0"/>
-              <a:pPr/>
-              <a:t>11/30/2025</a:t>
+              <a:t>12/2/2025</a:t>
             </a:fld>
             <a:endParaRPr lang="en-US"/>
           </a:p>
@@ -824,10 +1232,9 @@
           <a:bodyPr/>
           <a:lstStyle/>
           <a:p>
-            <a:fld id="{1D8BD707-D9CF-40AE-B4C6-C98DA3205C09}" type="datetimeFigureOut">
+            <a:fld id="{52B56737-861B-4959-9C60-074AAC73B472}" type="datetime1">
               <a:rPr lang="en-US" smtClean="0"/>
-              <a:pPr/>
-              <a:t>11/30/2025</a:t>
+              <a:t>12/2/2025</a:t>
             </a:fld>
             <a:endParaRPr lang="en-US"/>
           </a:p>
@@ -1066,10 +1473,9 @@
           <a:bodyPr/>
           <a:lstStyle/>
           <a:p>
-            <a:fld id="{1D8BD707-D9CF-40AE-B4C6-C98DA3205C09}" type="datetimeFigureOut">
+            <a:fld id="{C966D4B1-8A13-4251-A41C-372CBDDB8917}" type="datetime1">
               <a:rPr lang="en-US" smtClean="0"/>
-              <a:pPr/>
-              <a:t>11/30/2025</a:t>
+              <a:t>12/2/2025</a:t>
             </a:fld>
             <a:endParaRPr lang="en-US"/>
           </a:p>
@@ -1348,10 +1754,9 @@
           <a:bodyPr/>
           <a:lstStyle/>
           <a:p>
-            <a:fld id="{1D8BD707-D9CF-40AE-B4C6-C98DA3205C09}" type="datetimeFigureOut">
+            <a:fld id="{754A917F-4E98-4D41-8796-1B2CF10B83E5}" type="datetime1">
               <a:rPr lang="en-US" smtClean="0"/>
-              <a:pPr/>
-              <a:t>11/30/2025</a:t>
+              <a:t>12/2/2025</a:t>
             </a:fld>
             <a:endParaRPr lang="en-US"/>
           </a:p>
@@ -1764,10 +2169,9 @@
           <a:bodyPr/>
           <a:lstStyle/>
           <a:p>
-            <a:fld id="{1D8BD707-D9CF-40AE-B4C6-C98DA3205C09}" type="datetimeFigureOut">
+            <a:fld id="{A3824CCE-5EF6-4015-9F67-6658875882EC}" type="datetime1">
               <a:rPr lang="en-US" smtClean="0"/>
-              <a:pPr/>
-              <a:t>11/30/2025</a:t>
+              <a:t>12/2/2025</a:t>
             </a:fld>
             <a:endParaRPr lang="en-US"/>
           </a:p>
@@ -1878,10 +2282,9 @@
           <a:bodyPr/>
           <a:lstStyle/>
           <a:p>
-            <a:fld id="{1D8BD707-D9CF-40AE-B4C6-C98DA3205C09}" type="datetimeFigureOut">
+            <a:fld id="{9ED0D5BB-E8D6-43D6-AA60-0B8C64A0FD9D}" type="datetime1">
               <a:rPr lang="en-US" smtClean="0"/>
-              <a:pPr/>
-              <a:t>11/30/2025</a:t>
+              <a:t>12/2/2025</a:t>
             </a:fld>
             <a:endParaRPr lang="en-US"/>
           </a:p>
@@ -1970,10 +2373,9 @@
           <a:bodyPr/>
           <a:lstStyle/>
           <a:p>
-            <a:fld id="{1D8BD707-D9CF-40AE-B4C6-C98DA3205C09}" type="datetimeFigureOut">
+            <a:fld id="{315A25CB-95E4-442F-A0D2-0AFD9D7B51BC}" type="datetime1">
               <a:rPr lang="en-US" smtClean="0"/>
-              <a:pPr/>
-              <a:t>11/30/2025</a:t>
+              <a:t>12/2/2025</a:t>
             </a:fld>
             <a:endParaRPr lang="en-US"/>
           </a:p>
@@ -2242,10 +2644,9 @@
           <a:bodyPr/>
           <a:lstStyle/>
           <a:p>
-            <a:fld id="{1D8BD707-D9CF-40AE-B4C6-C98DA3205C09}" type="datetimeFigureOut">
+            <a:fld id="{DAF29532-E92F-4FB5-B3B8-2C218D994B91}" type="datetime1">
               <a:rPr lang="en-US" smtClean="0"/>
-              <a:pPr/>
-              <a:t>11/30/2025</a:t>
+              <a:t>12/2/2025</a:t>
             </a:fld>
             <a:endParaRPr lang="en-US"/>
           </a:p>
@@ -2491,10 +2892,9 @@
           <a:bodyPr/>
           <a:lstStyle/>
           <a:p>
-            <a:fld id="{1D8BD707-D9CF-40AE-B4C6-C98DA3205C09}" type="datetimeFigureOut">
+            <a:fld id="{A6FBAB1A-DAE0-424E-B439-31162A1F4D39}" type="datetime1">
               <a:rPr lang="en-US" smtClean="0"/>
-              <a:pPr/>
-              <a:t>11/30/2025</a:t>
+              <a:t>12/2/2025</a:t>
             </a:fld>
             <a:endParaRPr lang="en-US"/>
           </a:p>
@@ -2699,10 +3099,9 @@
             </a:lvl1pPr>
           </a:lstStyle>
           <a:p>
-            <a:fld id="{1D8BD707-D9CF-40AE-B4C6-C98DA3205C09}" type="datetimeFigureOut">
+            <a:fld id="{C08AAA80-E11B-44F0-B01B-889CA5A8CBB2}" type="datetime1">
               <a:rPr lang="en-US" smtClean="0"/>
-              <a:pPr/>
-              <a:t>11/30/2025</a:t>
+              <a:t>12/2/2025</a:t>
             </a:fld>
             <a:endParaRPr lang="en-US"/>
           </a:p>
@@ -2803,6 +3202,7 @@
     <p:sldLayoutId id="2147483658" r:id="rId10"/>
     <p:sldLayoutId id="2147483659" r:id="rId11"/>
   </p:sldLayoutIdLst>
+  <p:hf hdr="0" ftr="0" dt="0"/>
   <p:txStyles>
     <p:titleStyle>
       <a:lvl1pPr algn="ctr" defTabSz="914400" rtl="0" eaLnBrk="1" latinLnBrk="0" hangingPunct="1">
@@ -4391,252 +4791,33 @@
           </p:txBody>
         </p:sp>
       </p:grpSp>
-    </p:spTree>
-  </p:cSld>
-  <p:clrMapOvr>
-    <a:masterClrMapping/>
-  </p:clrMapOvr>
-</p:sld>
-</file>
-
-<file path=ppt/slides/slide2.xml><?xml version="1.0" encoding="utf-8"?>
-<p:sld xmlns:a="http://schemas.openxmlformats.org/drawingml/2006/main" xmlns:r="http://schemas.openxmlformats.org/officeDocument/2006/relationships" xmlns:p="http://schemas.openxmlformats.org/presentationml/2006/main">
-  <p:cSld>
-    <p:bg>
-      <p:bgPr>
-        <a:solidFill>
-          <a:srgbClr val="132232"/>
-        </a:solidFill>
-        <a:effectLst/>
-      </p:bgPr>
-    </p:bg>
-    <p:spTree>
-      <p:nvGrpSpPr>
-        <p:cNvPr id="1" name=""/>
-        <p:cNvGrpSpPr/>
-        <p:nvPr/>
-      </p:nvGrpSpPr>
-      <p:grpSpPr>
-        <a:xfrm>
-          <a:off x="0" y="0"/>
-          <a:ext cx="0" cy="0"/>
-          <a:chOff x="0" y="0"/>
-          <a:chExt cx="0" cy="0"/>
-        </a:xfrm>
-      </p:grpSpPr>
       <p:sp>
         <p:nvSpPr>
-          <p:cNvPr id="2" name="AutoShape 2"/>
-          <p:cNvSpPr/>
-          <p:nvPr/>
+          <p:cNvPr id="21" name="Marcador de número de diapositiva 20">
+            <a:extLst>
+              <a:ext uri="{FF2B5EF4-FFF2-40B4-BE49-F238E27FC236}">
+                <a16:creationId xmlns:a16="http://schemas.microsoft.com/office/drawing/2014/main" id="{5E2C91B6-2B7A-03A4-443C-CC0A9A68A58E}"/>
+              </a:ext>
+            </a:extLst>
+          </p:cNvPr>
+          <p:cNvSpPr>
+            <a:spLocks noGrp="1"/>
+          </p:cNvSpPr>
+          <p:nvPr>
+            <p:ph type="sldNum" sz="quarter" idx="12"/>
+          </p:nvPr>
         </p:nvSpPr>
-        <p:spPr>
-          <a:xfrm>
-            <a:off x="4940584" y="6465400"/>
-            <a:ext cx="13347416" cy="0"/>
-          </a:xfrm>
-          <a:prstGeom prst="line">
-            <a:avLst/>
-          </a:prstGeom>
-          <a:ln w="28575" cap="flat">
-            <a:solidFill>
-              <a:srgbClr val="FFFFFF"/>
-            </a:solidFill>
-            <a:prstDash val="solid"/>
-            <a:headEnd type="oval" w="lg" len="lg"/>
-            <a:tailEnd type="none" w="sm" len="sm"/>
-          </a:ln>
-        </p:spPr>
+        <p:spPr/>
         <p:txBody>
           <a:bodyPr/>
           <a:lstStyle/>
           <a:p>
-            <a:endParaRPr lang="es-AR"/>
-          </a:p>
-        </p:txBody>
-      </p:sp>
-      <p:sp>
-        <p:nvSpPr>
-          <p:cNvPr id="3" name="AutoShape 3"/>
-          <p:cNvSpPr/>
-          <p:nvPr/>
-        </p:nvSpPr>
-        <p:spPr>
-          <a:xfrm>
-            <a:off x="0" y="3285380"/>
-            <a:ext cx="13347416" cy="0"/>
-          </a:xfrm>
-          <a:prstGeom prst="line">
-            <a:avLst/>
-          </a:prstGeom>
-          <a:ln w="28575" cap="flat">
-            <a:solidFill>
-              <a:srgbClr val="FFFFFF"/>
-            </a:solidFill>
-            <a:prstDash val="solid"/>
-            <a:headEnd type="none" w="sm" len="sm"/>
-            <a:tailEnd type="oval" w="lg" len="lg"/>
-          </a:ln>
-        </p:spPr>
-        <p:txBody>
-          <a:bodyPr/>
-          <a:lstStyle/>
-          <a:p>
-            <a:endParaRPr lang="es-AR"/>
-          </a:p>
-        </p:txBody>
-      </p:sp>
-      <p:sp>
-        <p:nvSpPr>
-          <p:cNvPr id="4" name="TextBox 4"/>
-          <p:cNvSpPr txBox="1"/>
-          <p:nvPr/>
-        </p:nvSpPr>
-        <p:spPr>
-          <a:xfrm>
-            <a:off x="2413184" y="4223785"/>
-            <a:ext cx="12318716" cy="1174750"/>
-          </a:xfrm>
-          <a:prstGeom prst="rect">
-            <a:avLst/>
-          </a:prstGeom>
-        </p:spPr>
-        <p:txBody>
-          <a:bodyPr lIns="0" tIns="0" rIns="0" bIns="0" rtlCol="0" anchor="t">
-            <a:spAutoFit/>
-          </a:bodyPr>
-          <a:lstStyle/>
-          <a:p>
-            <a:pPr algn="l">
-              <a:lnSpc>
-                <a:spcPts val="9200"/>
-              </a:lnSpc>
-            </a:pPr>
-            <a:r>
-              <a:rPr lang="en-US" sz="8000" spc="344">
-                <a:solidFill>
-                  <a:srgbClr val="FFFFFF"/>
-                </a:solidFill>
-                <a:latin typeface="Oswald"/>
-                <a:ea typeface="Oswald"/>
-                <a:cs typeface="Oswald"/>
-                <a:sym typeface="Oswald"/>
-              </a:rPr>
-              <a:t>PROPUESTA DE TRABAJO</a:t>
-            </a:r>
-          </a:p>
-        </p:txBody>
-      </p:sp>
-      <p:sp>
-        <p:nvSpPr>
-          <p:cNvPr id="5" name="TextBox 5"/>
-          <p:cNvSpPr txBox="1"/>
-          <p:nvPr/>
-        </p:nvSpPr>
-        <p:spPr>
-          <a:xfrm>
-            <a:off x="2413184" y="5430501"/>
-            <a:ext cx="14519718" cy="2295371"/>
-          </a:xfrm>
-          <a:prstGeom prst="rect">
-            <a:avLst/>
-          </a:prstGeom>
-        </p:spPr>
-        <p:txBody>
-          <a:bodyPr lIns="0" tIns="0" rIns="0" bIns="0" rtlCol="0" anchor="t">
-            <a:spAutoFit/>
-          </a:bodyPr>
-          <a:lstStyle/>
-          <a:p>
-            <a:pPr algn="just">
-              <a:lnSpc>
-                <a:spcPts val="4480"/>
-              </a:lnSpc>
-            </a:pPr>
-            <a:r>
-              <a:rPr lang="en-US" sz="3420" spc="68">
-                <a:solidFill>
-                  <a:srgbClr val="FFFFFF"/>
-                </a:solidFill>
-                <a:latin typeface="Codec Pro"/>
-                <a:ea typeface="Codec Pro"/>
-                <a:cs typeface="Codec Pro"/>
-                <a:sym typeface="Codec Pro"/>
-              </a:rPr>
-              <a:t>SE APLICARON CLUSTER DINAMICOS SOBRE LA BASE INMOBILIARIA MENSUAL DE ZONA PROP DURANTE EL PERIODO 2016-2025. EL OBJETIVO ES IFDENTIFICAR COMO EVOLUCIONARON LOS PRECIOS DEL M2 EN CADA UNO DE LOS CLUSTER DESIGNADOS</a:t>
-            </a:r>
-          </a:p>
-        </p:txBody>
-      </p:sp>
-      <p:sp>
-        <p:nvSpPr>
-          <p:cNvPr id="6" name="TextBox 6"/>
-          <p:cNvSpPr txBox="1"/>
-          <p:nvPr/>
-        </p:nvSpPr>
-        <p:spPr>
-          <a:xfrm>
-            <a:off x="442957" y="3854852"/>
-            <a:ext cx="1728747" cy="2388683"/>
-          </a:xfrm>
-          <a:prstGeom prst="rect">
-            <a:avLst/>
-          </a:prstGeom>
-        </p:spPr>
-        <p:txBody>
-          <a:bodyPr lIns="0" tIns="0" rIns="0" bIns="0" rtlCol="0" anchor="t">
-            <a:spAutoFit/>
-          </a:bodyPr>
-          <a:lstStyle/>
-          <a:p>
-            <a:pPr algn="ctr">
-              <a:lnSpc>
-                <a:spcPts val="18616"/>
-              </a:lnSpc>
-            </a:pPr>
-            <a:r>
-              <a:rPr lang="en-US" sz="16188" spc="696">
-                <a:solidFill>
-                  <a:srgbClr val="FFFFFF"/>
-                </a:solidFill>
-                <a:latin typeface="Oswald"/>
-                <a:ea typeface="Oswald"/>
-                <a:cs typeface="Oswald"/>
-                <a:sym typeface="Oswald"/>
-              </a:rPr>
+            <a:fld id="{B6F15528-21DE-4FAA-801E-634DDDAF4B2B}" type="slidenum">
+              <a:rPr lang="en-US" smtClean="0"/>
+              <a:pPr/>
               <a:t>1</a:t>
-            </a:r>
-          </a:p>
-        </p:txBody>
-      </p:sp>
-      <p:sp>
-        <p:nvSpPr>
-          <p:cNvPr id="7" name="AutoShape 7"/>
-          <p:cNvSpPr/>
-          <p:nvPr/>
-        </p:nvSpPr>
-        <p:spPr>
-          <a:xfrm>
-            <a:off x="1732555" y="5114925"/>
-            <a:ext cx="439149" cy="0"/>
-          </a:xfrm>
-          <a:prstGeom prst="line">
-            <a:avLst/>
-          </a:prstGeom>
-          <a:ln w="19050" cap="flat">
-            <a:solidFill>
-              <a:srgbClr val="FFFFFF"/>
-            </a:solidFill>
-            <a:prstDash val="solid"/>
-            <a:headEnd type="none" w="sm" len="sm"/>
-            <a:tailEnd type="none" w="sm" len="sm"/>
-          </a:ln>
-        </p:spPr>
-        <p:txBody>
-          <a:bodyPr/>
-          <a:lstStyle/>
-          <a:p>
-            <a:endParaRPr lang="es-AR"/>
+            </a:fld>
+            <a:endParaRPr lang="en-US"/>
           </a:p>
         </p:txBody>
       </p:sp>
@@ -4648,7 +4829,7 @@
 </p:sld>
 </file>
 
-<file path=ppt/slides/slide3.xml><?xml version="1.0" encoding="utf-8"?>
+<file path=ppt/slides/slide2.xml><?xml version="1.0" encoding="utf-8"?>
 <p:sld xmlns:a="http://schemas.openxmlformats.org/drawingml/2006/main" xmlns:r="http://schemas.openxmlformats.org/officeDocument/2006/relationships" xmlns:p="http://schemas.openxmlformats.org/presentationml/2006/main">
   <p:cSld>
     <p:spTree>
@@ -4784,16 +4965,124 @@
               <a:buChar char="•"/>
             </a:pPr>
             <a:r>
-              <a:rPr lang="en-US" sz="2799" u="none" spc="55">
-                <a:solidFill>
-                  <a:srgbClr val="000000"/>
-                </a:solidFill>
-                <a:latin typeface="Codec Pro"/>
-                <a:ea typeface="Codec Pro"/>
-                <a:cs typeface="Codec Pro"/>
-                <a:sym typeface="Codec Pro"/>
-              </a:rPr>
-              <a:t>Aplicación de clustering dinámico a datos inmobiliarios de ZonaProp (2016–2025).</a:t>
+              <a:rPr lang="en-US" sz="2799" u="none" spc="55" dirty="0" err="1">
+                <a:solidFill>
+                  <a:srgbClr val="000000"/>
+                </a:solidFill>
+                <a:latin typeface="Codec Pro"/>
+                <a:ea typeface="Codec Pro"/>
+                <a:cs typeface="Codec Pro"/>
+                <a:sym typeface="Codec Pro"/>
+              </a:rPr>
+              <a:t>Aplicación</a:t>
+            </a:r>
+            <a:r>
+              <a:rPr lang="en-US" sz="2799" u="none" spc="55" dirty="0">
+                <a:solidFill>
+                  <a:srgbClr val="000000"/>
+                </a:solidFill>
+                <a:latin typeface="Codec Pro"/>
+                <a:ea typeface="Codec Pro"/>
+                <a:cs typeface="Codec Pro"/>
+                <a:sym typeface="Codec Pro"/>
+              </a:rPr>
+              <a:t> de clustering </a:t>
+            </a:r>
+            <a:r>
+              <a:rPr lang="en-US" sz="2799" u="none" spc="55" dirty="0" err="1">
+                <a:solidFill>
+                  <a:srgbClr val="000000"/>
+                </a:solidFill>
+                <a:latin typeface="Codec Pro"/>
+                <a:ea typeface="Codec Pro"/>
+                <a:cs typeface="Codec Pro"/>
+                <a:sym typeface="Codec Pro"/>
+              </a:rPr>
+              <a:t>dinámico</a:t>
+            </a:r>
+            <a:r>
+              <a:rPr lang="en-US" sz="2799" u="none" spc="55" dirty="0">
+                <a:solidFill>
+                  <a:srgbClr val="000000"/>
+                </a:solidFill>
+                <a:latin typeface="Codec Pro"/>
+                <a:ea typeface="Codec Pro"/>
+                <a:cs typeface="Codec Pro"/>
+                <a:sym typeface="Codec Pro"/>
+              </a:rPr>
+              <a:t> a </a:t>
+            </a:r>
+            <a:r>
+              <a:rPr lang="en-US" sz="2799" u="none" spc="55" dirty="0" err="1">
+                <a:solidFill>
+                  <a:srgbClr val="000000"/>
+                </a:solidFill>
+                <a:latin typeface="Codec Pro"/>
+                <a:ea typeface="Codec Pro"/>
+                <a:cs typeface="Codec Pro"/>
+                <a:sym typeface="Codec Pro"/>
+              </a:rPr>
+              <a:t>datos</a:t>
+            </a:r>
+            <a:r>
+              <a:rPr lang="en-US" sz="2799" u="none" spc="55" dirty="0">
+                <a:solidFill>
+                  <a:srgbClr val="000000"/>
+                </a:solidFill>
+                <a:latin typeface="Codec Pro"/>
+                <a:ea typeface="Codec Pro"/>
+                <a:cs typeface="Codec Pro"/>
+                <a:sym typeface="Codec Pro"/>
+              </a:rPr>
+              <a:t> </a:t>
+            </a:r>
+            <a:r>
+              <a:rPr lang="en-US" sz="2799" u="none" spc="55" dirty="0" err="1">
+                <a:solidFill>
+                  <a:srgbClr val="000000"/>
+                </a:solidFill>
+                <a:latin typeface="Codec Pro"/>
+                <a:ea typeface="Codec Pro"/>
+                <a:cs typeface="Codec Pro"/>
+                <a:sym typeface="Codec Pro"/>
+              </a:rPr>
+              <a:t>inmobiliarios</a:t>
+            </a:r>
+            <a:r>
+              <a:rPr lang="en-US" sz="2799" u="none" spc="55" dirty="0">
+                <a:solidFill>
+                  <a:srgbClr val="000000"/>
+                </a:solidFill>
+                <a:latin typeface="Codec Pro"/>
+                <a:ea typeface="Codec Pro"/>
+                <a:cs typeface="Codec Pro"/>
+                <a:sym typeface="Codec Pro"/>
+              </a:rPr>
+              <a:t> de </a:t>
+            </a:r>
+            <a:r>
+              <a:rPr lang="en-US" sz="2799" u="none" spc="55" dirty="0" err="1">
+                <a:solidFill>
+                  <a:srgbClr val="000000"/>
+                </a:solidFill>
+                <a:latin typeface="Codec Pro"/>
+                <a:ea typeface="Codec Pro"/>
+                <a:cs typeface="Codec Pro"/>
+                <a:sym typeface="Codec Pro"/>
+              </a:rPr>
+              <a:t>ZonaProp</a:t>
+            </a:r>
+            <a:r>
+              <a:rPr lang="en-US" sz="2799" u="none" spc="55" dirty="0">
+                <a:solidFill>
+                  <a:srgbClr val="000000"/>
+                </a:solidFill>
+                <a:latin typeface="Codec Pro"/>
+                <a:ea typeface="Codec Pro"/>
+                <a:cs typeface="Codec Pro"/>
+                <a:sym typeface="Codec Pro"/>
+              </a:rPr>
+              <a:t> (2016–2025).</a:t>
             </a:r>
           </a:p>
           <a:p>
@@ -4802,7 +5091,7 @@
                 <a:spcPts val="3667"/>
               </a:lnSpc>
             </a:pPr>
-            <a:endParaRPr lang="en-US" sz="2799" u="none" spc="55">
+            <a:endParaRPr lang="en-US" sz="2799" u="none" spc="55" dirty="0">
               <a:solidFill>
                 <a:srgbClr val="000000"/>
               </a:solidFill>
@@ -4821,16 +5110,124 @@
               <a:buChar char="•"/>
             </a:pPr>
             <a:r>
-              <a:rPr lang="en-US" sz="2799" u="none" spc="55">
-                <a:solidFill>
-                  <a:srgbClr val="000000"/>
-                </a:solidFill>
-                <a:latin typeface="Codec Pro"/>
-                <a:ea typeface="Codec Pro"/>
-                <a:cs typeface="Codec Pro"/>
-                <a:sym typeface="Codec Pro"/>
-              </a:rPr>
-              <a:t>Identificación de grupos de propiedades con características similares.</a:t>
+              <a:rPr lang="en-US" sz="2799" u="none" spc="55" dirty="0" err="1">
+                <a:solidFill>
+                  <a:srgbClr val="000000"/>
+                </a:solidFill>
+                <a:latin typeface="Codec Pro"/>
+                <a:ea typeface="Codec Pro"/>
+                <a:cs typeface="Codec Pro"/>
+                <a:sym typeface="Codec Pro"/>
+              </a:rPr>
+              <a:t>Identificación</a:t>
+            </a:r>
+            <a:r>
+              <a:rPr lang="en-US" sz="2799" u="none" spc="55" dirty="0">
+                <a:solidFill>
+                  <a:srgbClr val="000000"/>
+                </a:solidFill>
+                <a:latin typeface="Codec Pro"/>
+                <a:ea typeface="Codec Pro"/>
+                <a:cs typeface="Codec Pro"/>
+                <a:sym typeface="Codec Pro"/>
+              </a:rPr>
+              <a:t> de </a:t>
+            </a:r>
+            <a:r>
+              <a:rPr lang="en-US" sz="2799" u="none" spc="55" dirty="0" err="1">
+                <a:solidFill>
+                  <a:srgbClr val="000000"/>
+                </a:solidFill>
+                <a:latin typeface="Codec Pro"/>
+                <a:ea typeface="Codec Pro"/>
+                <a:cs typeface="Codec Pro"/>
+                <a:sym typeface="Codec Pro"/>
+              </a:rPr>
+              <a:t>grupos</a:t>
+            </a:r>
+            <a:r>
+              <a:rPr lang="en-US" sz="2799" u="none" spc="55" dirty="0">
+                <a:solidFill>
+                  <a:srgbClr val="000000"/>
+                </a:solidFill>
+                <a:latin typeface="Codec Pro"/>
+                <a:ea typeface="Codec Pro"/>
+                <a:cs typeface="Codec Pro"/>
+                <a:sym typeface="Codec Pro"/>
+              </a:rPr>
+              <a:t> de </a:t>
+            </a:r>
+            <a:r>
+              <a:rPr lang="en-US" sz="2799" u="none" spc="55" dirty="0" err="1">
+                <a:solidFill>
+                  <a:srgbClr val="000000"/>
+                </a:solidFill>
+                <a:latin typeface="Codec Pro"/>
+                <a:ea typeface="Codec Pro"/>
+                <a:cs typeface="Codec Pro"/>
+                <a:sym typeface="Codec Pro"/>
+              </a:rPr>
+              <a:t>propiedades</a:t>
+            </a:r>
+            <a:r>
+              <a:rPr lang="en-US" sz="2799" u="none" spc="55" dirty="0">
+                <a:solidFill>
+                  <a:srgbClr val="000000"/>
+                </a:solidFill>
+                <a:latin typeface="Codec Pro"/>
+                <a:ea typeface="Codec Pro"/>
+                <a:cs typeface="Codec Pro"/>
+                <a:sym typeface="Codec Pro"/>
+              </a:rPr>
+              <a:t> con </a:t>
+            </a:r>
+            <a:r>
+              <a:rPr lang="en-US" sz="2799" u="none" spc="55" dirty="0" err="1">
+                <a:solidFill>
+                  <a:srgbClr val="000000"/>
+                </a:solidFill>
+                <a:latin typeface="Codec Pro"/>
+                <a:ea typeface="Codec Pro"/>
+                <a:cs typeface="Codec Pro"/>
+                <a:sym typeface="Codec Pro"/>
+              </a:rPr>
+              <a:t>características</a:t>
+            </a:r>
+            <a:r>
+              <a:rPr lang="en-US" sz="2799" u="none" spc="55" dirty="0">
+                <a:solidFill>
+                  <a:srgbClr val="000000"/>
+                </a:solidFill>
+                <a:latin typeface="Codec Pro"/>
+                <a:ea typeface="Codec Pro"/>
+                <a:cs typeface="Codec Pro"/>
+                <a:sym typeface="Codec Pro"/>
+              </a:rPr>
+              <a:t> </a:t>
+            </a:r>
+            <a:r>
+              <a:rPr lang="en-US" sz="2799" u="none" spc="55" dirty="0" err="1">
+                <a:solidFill>
+                  <a:srgbClr val="000000"/>
+                </a:solidFill>
+                <a:latin typeface="Codec Pro"/>
+                <a:ea typeface="Codec Pro"/>
+                <a:cs typeface="Codec Pro"/>
+                <a:sym typeface="Codec Pro"/>
+              </a:rPr>
+              <a:t>similares</a:t>
+            </a:r>
+            <a:r>
+              <a:rPr lang="en-US" sz="2799" u="none" spc="55" dirty="0">
+                <a:solidFill>
+                  <a:srgbClr val="000000"/>
+                </a:solidFill>
+                <a:latin typeface="Codec Pro"/>
+                <a:ea typeface="Codec Pro"/>
+                <a:cs typeface="Codec Pro"/>
+                <a:sym typeface="Codec Pro"/>
+              </a:rPr>
+              <a:t>.</a:t>
             </a:r>
           </a:p>
           <a:p>
@@ -4839,7 +5236,7 @@
                 <a:spcPts val="4322"/>
               </a:lnSpc>
             </a:pPr>
-            <a:endParaRPr lang="en-US" sz="2799" u="none" spc="55">
+            <a:endParaRPr lang="en-US" sz="2799" u="none" spc="55" dirty="0">
               <a:solidFill>
                 <a:srgbClr val="000000"/>
               </a:solidFill>
@@ -4858,16 +5255,148 @@
               <a:buChar char="•"/>
             </a:pPr>
             <a:r>
-              <a:rPr lang="en-US" sz="2799" u="none" spc="55">
-                <a:solidFill>
-                  <a:srgbClr val="000000"/>
-                </a:solidFill>
-                <a:latin typeface="Codec Pro"/>
-                <a:ea typeface="Codec Pro"/>
-                <a:cs typeface="Codec Pro"/>
-                <a:sym typeface="Codec Pro"/>
-              </a:rPr>
-              <a:t>Análisis de la evolución temporal de los precios del m² en cada cluster.</a:t>
+              <a:rPr lang="en-US" sz="2799" u="none" spc="55" dirty="0" err="1">
+                <a:solidFill>
+                  <a:srgbClr val="000000"/>
+                </a:solidFill>
+                <a:latin typeface="Codec Pro"/>
+                <a:ea typeface="Codec Pro"/>
+                <a:cs typeface="Codec Pro"/>
+                <a:sym typeface="Codec Pro"/>
+              </a:rPr>
+              <a:t>Análisis</a:t>
+            </a:r>
+            <a:r>
+              <a:rPr lang="en-US" sz="2799" u="none" spc="55" dirty="0">
+                <a:solidFill>
+                  <a:srgbClr val="000000"/>
+                </a:solidFill>
+                <a:latin typeface="Codec Pro"/>
+                <a:ea typeface="Codec Pro"/>
+                <a:cs typeface="Codec Pro"/>
+                <a:sym typeface="Codec Pro"/>
+              </a:rPr>
+              <a:t> de la </a:t>
+            </a:r>
+            <a:r>
+              <a:rPr lang="en-US" sz="2799" u="none" spc="55" dirty="0" err="1">
+                <a:solidFill>
+                  <a:srgbClr val="000000"/>
+                </a:solidFill>
+                <a:latin typeface="Codec Pro"/>
+                <a:ea typeface="Codec Pro"/>
+                <a:cs typeface="Codec Pro"/>
+                <a:sym typeface="Codec Pro"/>
+              </a:rPr>
+              <a:t>evolución</a:t>
+            </a:r>
+            <a:r>
+              <a:rPr lang="en-US" sz="2799" u="none" spc="55" dirty="0">
+                <a:solidFill>
+                  <a:srgbClr val="000000"/>
+                </a:solidFill>
+                <a:latin typeface="Codec Pro"/>
+                <a:ea typeface="Codec Pro"/>
+                <a:cs typeface="Codec Pro"/>
+                <a:sym typeface="Codec Pro"/>
+              </a:rPr>
+              <a:t> temporal de </a:t>
+            </a:r>
+            <a:r>
+              <a:rPr lang="en-US" sz="2799" u="none" spc="55" dirty="0" err="1">
+                <a:solidFill>
+                  <a:srgbClr val="000000"/>
+                </a:solidFill>
+                <a:latin typeface="Codec Pro"/>
+                <a:ea typeface="Codec Pro"/>
+                <a:cs typeface="Codec Pro"/>
+                <a:sym typeface="Codec Pro"/>
+              </a:rPr>
+              <a:t>los</a:t>
+            </a:r>
+            <a:r>
+              <a:rPr lang="en-US" sz="2799" u="none" spc="55" dirty="0">
+                <a:solidFill>
+                  <a:srgbClr val="000000"/>
+                </a:solidFill>
+                <a:latin typeface="Codec Pro"/>
+                <a:ea typeface="Codec Pro"/>
+                <a:cs typeface="Codec Pro"/>
+                <a:sym typeface="Codec Pro"/>
+              </a:rPr>
+              <a:t> </a:t>
+            </a:r>
+            <a:r>
+              <a:rPr lang="en-US" sz="2799" u="none" spc="55" dirty="0" err="1">
+                <a:solidFill>
+                  <a:srgbClr val="000000"/>
+                </a:solidFill>
+                <a:latin typeface="Codec Pro"/>
+                <a:ea typeface="Codec Pro"/>
+                <a:cs typeface="Codec Pro"/>
+                <a:sym typeface="Codec Pro"/>
+              </a:rPr>
+              <a:t>precios</a:t>
+            </a:r>
+            <a:r>
+              <a:rPr lang="en-US" sz="2799" u="none" spc="55" dirty="0">
+                <a:solidFill>
+                  <a:srgbClr val="000000"/>
+                </a:solidFill>
+                <a:latin typeface="Codec Pro"/>
+                <a:ea typeface="Codec Pro"/>
+                <a:cs typeface="Codec Pro"/>
+                <a:sym typeface="Codec Pro"/>
+              </a:rPr>
+              <a:t> del m² </a:t>
+            </a:r>
+            <a:r>
+              <a:rPr lang="en-US" sz="2799" u="none" spc="55" dirty="0" err="1">
+                <a:solidFill>
+                  <a:srgbClr val="000000"/>
+                </a:solidFill>
+                <a:latin typeface="Codec Pro"/>
+                <a:ea typeface="Codec Pro"/>
+                <a:cs typeface="Codec Pro"/>
+                <a:sym typeface="Codec Pro"/>
+              </a:rPr>
+              <a:t>en</a:t>
+            </a:r>
+            <a:r>
+              <a:rPr lang="en-US" sz="2799" u="none" spc="55" dirty="0">
+                <a:solidFill>
+                  <a:srgbClr val="000000"/>
+                </a:solidFill>
+                <a:latin typeface="Codec Pro"/>
+                <a:ea typeface="Codec Pro"/>
+                <a:cs typeface="Codec Pro"/>
+                <a:sym typeface="Codec Pro"/>
+              </a:rPr>
+              <a:t> </a:t>
+            </a:r>
+            <a:r>
+              <a:rPr lang="en-US" sz="2799" u="none" spc="55" dirty="0" err="1">
+                <a:solidFill>
+                  <a:srgbClr val="000000"/>
+                </a:solidFill>
+                <a:latin typeface="Codec Pro"/>
+                <a:ea typeface="Codec Pro"/>
+                <a:cs typeface="Codec Pro"/>
+                <a:sym typeface="Codec Pro"/>
+              </a:rPr>
+              <a:t>cada</a:t>
+            </a:r>
+            <a:r>
+              <a:rPr lang="en-US" sz="2799" u="none" spc="55" dirty="0">
+                <a:solidFill>
+                  <a:srgbClr val="000000"/>
+                </a:solidFill>
+                <a:latin typeface="Codec Pro"/>
+                <a:ea typeface="Codec Pro"/>
+                <a:cs typeface="Codec Pro"/>
+                <a:sym typeface="Codec Pro"/>
+              </a:rPr>
+              <a:t> cluster.</a:t>
             </a:r>
           </a:p>
           <a:p>
@@ -4876,7 +5405,7 @@
                 <a:spcPts val="3667"/>
               </a:lnSpc>
             </a:pPr>
-            <a:endParaRPr lang="en-US" sz="2799" u="none" spc="55">
+            <a:endParaRPr lang="en-US" sz="2799" u="none" spc="55" dirty="0">
               <a:solidFill>
                 <a:srgbClr val="000000"/>
               </a:solidFill>
@@ -4895,16 +5424,172 @@
               <a:buChar char="•"/>
             </a:pPr>
             <a:r>
-              <a:rPr lang="en-US" sz="2799" u="none" spc="55">
-                <a:solidFill>
-                  <a:srgbClr val="000000"/>
-                </a:solidFill>
-                <a:latin typeface="Codec Pro"/>
-                <a:ea typeface="Codec Pro"/>
-                <a:cs typeface="Codec Pro"/>
-                <a:sym typeface="Codec Pro"/>
-              </a:rPr>
-              <a:t>Evaluar cómo cambian los patrones del mercado frente a shocks o ciclos.</a:t>
+              <a:rPr lang="en-US" sz="2799" u="none" spc="55" dirty="0" err="1">
+                <a:solidFill>
+                  <a:srgbClr val="000000"/>
+                </a:solidFill>
+                <a:latin typeface="Codec Pro"/>
+                <a:ea typeface="Codec Pro"/>
+                <a:cs typeface="Codec Pro"/>
+                <a:sym typeface="Codec Pro"/>
+              </a:rPr>
+              <a:t>Evaluar</a:t>
+            </a:r>
+            <a:r>
+              <a:rPr lang="en-US" sz="2799" u="none" spc="55" dirty="0">
+                <a:solidFill>
+                  <a:srgbClr val="000000"/>
+                </a:solidFill>
+                <a:latin typeface="Codec Pro"/>
+                <a:ea typeface="Codec Pro"/>
+                <a:cs typeface="Codec Pro"/>
+                <a:sym typeface="Codec Pro"/>
+              </a:rPr>
+              <a:t> </a:t>
+            </a:r>
+            <a:r>
+              <a:rPr lang="en-US" sz="2799" u="none" spc="55" dirty="0" err="1">
+                <a:solidFill>
+                  <a:srgbClr val="000000"/>
+                </a:solidFill>
+                <a:latin typeface="Codec Pro"/>
+                <a:ea typeface="Codec Pro"/>
+                <a:cs typeface="Codec Pro"/>
+                <a:sym typeface="Codec Pro"/>
+              </a:rPr>
+              <a:t>cómo</a:t>
+            </a:r>
+            <a:r>
+              <a:rPr lang="en-US" sz="2799" u="none" spc="55" dirty="0">
+                <a:solidFill>
+                  <a:srgbClr val="000000"/>
+                </a:solidFill>
+                <a:latin typeface="Codec Pro"/>
+                <a:ea typeface="Codec Pro"/>
+                <a:cs typeface="Codec Pro"/>
+                <a:sym typeface="Codec Pro"/>
+              </a:rPr>
+              <a:t> </a:t>
+            </a:r>
+            <a:r>
+              <a:rPr lang="en-US" sz="2799" u="none" spc="55" dirty="0" err="1">
+                <a:solidFill>
+                  <a:srgbClr val="000000"/>
+                </a:solidFill>
+                <a:latin typeface="Codec Pro"/>
+                <a:ea typeface="Codec Pro"/>
+                <a:cs typeface="Codec Pro"/>
+                <a:sym typeface="Codec Pro"/>
+              </a:rPr>
+              <a:t>cambian</a:t>
+            </a:r>
+            <a:r>
+              <a:rPr lang="en-US" sz="2799" u="none" spc="55" dirty="0">
+                <a:solidFill>
+                  <a:srgbClr val="000000"/>
+                </a:solidFill>
+                <a:latin typeface="Codec Pro"/>
+                <a:ea typeface="Codec Pro"/>
+                <a:cs typeface="Codec Pro"/>
+                <a:sym typeface="Codec Pro"/>
+              </a:rPr>
+              <a:t> </a:t>
+            </a:r>
+            <a:r>
+              <a:rPr lang="en-US" sz="2799" u="none" spc="55" dirty="0" err="1">
+                <a:solidFill>
+                  <a:srgbClr val="000000"/>
+                </a:solidFill>
+                <a:latin typeface="Codec Pro"/>
+                <a:ea typeface="Codec Pro"/>
+                <a:cs typeface="Codec Pro"/>
+                <a:sym typeface="Codec Pro"/>
+              </a:rPr>
+              <a:t>los</a:t>
+            </a:r>
+            <a:r>
+              <a:rPr lang="en-US" sz="2799" u="none" spc="55" dirty="0">
+                <a:solidFill>
+                  <a:srgbClr val="000000"/>
+                </a:solidFill>
+                <a:latin typeface="Codec Pro"/>
+                <a:ea typeface="Codec Pro"/>
+                <a:cs typeface="Codec Pro"/>
+                <a:sym typeface="Codec Pro"/>
+              </a:rPr>
+              <a:t> </a:t>
+            </a:r>
+            <a:r>
+              <a:rPr lang="en-US" sz="2799" u="none" spc="55" dirty="0" err="1">
+                <a:solidFill>
+                  <a:srgbClr val="000000"/>
+                </a:solidFill>
+                <a:latin typeface="Codec Pro"/>
+                <a:ea typeface="Codec Pro"/>
+                <a:cs typeface="Codec Pro"/>
+                <a:sym typeface="Codec Pro"/>
+              </a:rPr>
+              <a:t>patrones</a:t>
+            </a:r>
+            <a:r>
+              <a:rPr lang="en-US" sz="2799" u="none" spc="55" dirty="0">
+                <a:solidFill>
+                  <a:srgbClr val="000000"/>
+                </a:solidFill>
+                <a:latin typeface="Codec Pro"/>
+                <a:ea typeface="Codec Pro"/>
+                <a:cs typeface="Codec Pro"/>
+                <a:sym typeface="Codec Pro"/>
+              </a:rPr>
+              <a:t> del mercado </a:t>
+            </a:r>
+            <a:r>
+              <a:rPr lang="en-US" sz="2799" u="none" spc="55" dirty="0" err="1">
+                <a:solidFill>
+                  <a:srgbClr val="000000"/>
+                </a:solidFill>
+                <a:latin typeface="Codec Pro"/>
+                <a:ea typeface="Codec Pro"/>
+                <a:cs typeface="Codec Pro"/>
+                <a:sym typeface="Codec Pro"/>
+              </a:rPr>
+              <a:t>frente</a:t>
+            </a:r>
+            <a:r>
+              <a:rPr lang="en-US" sz="2799" u="none" spc="55" dirty="0">
+                <a:solidFill>
+                  <a:srgbClr val="000000"/>
+                </a:solidFill>
+                <a:latin typeface="Codec Pro"/>
+                <a:ea typeface="Codec Pro"/>
+                <a:cs typeface="Codec Pro"/>
+                <a:sym typeface="Codec Pro"/>
+              </a:rPr>
+              <a:t> a shocks o </a:t>
+            </a:r>
+            <a:r>
+              <a:rPr lang="en-US" sz="2799" u="none" spc="55" dirty="0" err="1">
+                <a:solidFill>
+                  <a:srgbClr val="000000"/>
+                </a:solidFill>
+                <a:latin typeface="Codec Pro"/>
+                <a:ea typeface="Codec Pro"/>
+                <a:cs typeface="Codec Pro"/>
+                <a:sym typeface="Codec Pro"/>
+              </a:rPr>
+              <a:t>ciclos</a:t>
+            </a:r>
+            <a:r>
+              <a:rPr lang="en-US" sz="2799" u="none" spc="55" dirty="0">
+                <a:solidFill>
+                  <a:srgbClr val="000000"/>
+                </a:solidFill>
+                <a:latin typeface="Codec Pro"/>
+                <a:ea typeface="Codec Pro"/>
+                <a:cs typeface="Codec Pro"/>
+                <a:sym typeface="Codec Pro"/>
+              </a:rPr>
+              <a:t>.</a:t>
             </a:r>
           </a:p>
           <a:p>
@@ -4913,7 +5598,7 @@
                 <a:spcPts val="4453"/>
               </a:lnSpc>
             </a:pPr>
-            <a:endParaRPr lang="en-US" sz="2799" u="none" spc="55">
+            <a:endParaRPr lang="en-US" sz="2799" u="none" spc="55" dirty="0">
               <a:solidFill>
                 <a:srgbClr val="000000"/>
               </a:solidFill>
@@ -4932,16 +5617,172 @@
               <a:buChar char="•"/>
             </a:pPr>
             <a:r>
-              <a:rPr lang="en-US" sz="2799" u="none" spc="55">
-                <a:solidFill>
-                  <a:srgbClr val="000000"/>
-                </a:solidFill>
-                <a:latin typeface="Codec Pro"/>
-                <a:ea typeface="Codec Pro"/>
-                <a:cs typeface="Codec Pro"/>
-                <a:sym typeface="Codec Pro"/>
-              </a:rPr>
-              <a:t>Generar información útil para inversores, desarrolladores y análisis urbano.</a:t>
+              <a:rPr lang="en-US" sz="2799" u="none" spc="55" dirty="0" err="1">
+                <a:solidFill>
+                  <a:srgbClr val="000000"/>
+                </a:solidFill>
+                <a:latin typeface="Codec Pro"/>
+                <a:ea typeface="Codec Pro"/>
+                <a:cs typeface="Codec Pro"/>
+                <a:sym typeface="Codec Pro"/>
+              </a:rPr>
+              <a:t>Generar</a:t>
+            </a:r>
+            <a:r>
+              <a:rPr lang="en-US" sz="2799" u="none" spc="55" dirty="0">
+                <a:solidFill>
+                  <a:srgbClr val="000000"/>
+                </a:solidFill>
+                <a:latin typeface="Codec Pro"/>
+                <a:ea typeface="Codec Pro"/>
+                <a:cs typeface="Codec Pro"/>
+                <a:sym typeface="Codec Pro"/>
+              </a:rPr>
+              <a:t> </a:t>
+            </a:r>
+            <a:r>
+              <a:rPr lang="en-US" sz="2799" u="none" spc="55" dirty="0" err="1">
+                <a:solidFill>
+                  <a:srgbClr val="000000"/>
+                </a:solidFill>
+                <a:latin typeface="Codec Pro"/>
+                <a:ea typeface="Codec Pro"/>
+                <a:cs typeface="Codec Pro"/>
+                <a:sym typeface="Codec Pro"/>
+              </a:rPr>
+              <a:t>información</a:t>
+            </a:r>
+            <a:r>
+              <a:rPr lang="en-US" sz="2799" u="none" spc="55" dirty="0">
+                <a:solidFill>
+                  <a:srgbClr val="000000"/>
+                </a:solidFill>
+                <a:latin typeface="Codec Pro"/>
+                <a:ea typeface="Codec Pro"/>
+                <a:cs typeface="Codec Pro"/>
+                <a:sym typeface="Codec Pro"/>
+              </a:rPr>
+              <a:t> </a:t>
+            </a:r>
+            <a:r>
+              <a:rPr lang="en-US" sz="2799" u="none" spc="55" dirty="0" err="1">
+                <a:solidFill>
+                  <a:srgbClr val="000000"/>
+                </a:solidFill>
+                <a:latin typeface="Codec Pro"/>
+                <a:ea typeface="Codec Pro"/>
+                <a:cs typeface="Codec Pro"/>
+                <a:sym typeface="Codec Pro"/>
+              </a:rPr>
+              <a:t>útil</a:t>
+            </a:r>
+            <a:r>
+              <a:rPr lang="en-US" sz="2799" u="none" spc="55" dirty="0">
+                <a:solidFill>
+                  <a:srgbClr val="000000"/>
+                </a:solidFill>
+                <a:latin typeface="Codec Pro"/>
+                <a:ea typeface="Codec Pro"/>
+                <a:cs typeface="Codec Pro"/>
+                <a:sym typeface="Codec Pro"/>
+              </a:rPr>
+              <a:t> para </a:t>
+            </a:r>
+            <a:r>
+              <a:rPr lang="en-US" sz="2799" u="none" spc="55" dirty="0" err="1">
+                <a:solidFill>
+                  <a:srgbClr val="000000"/>
+                </a:solidFill>
+                <a:latin typeface="Codec Pro"/>
+                <a:ea typeface="Codec Pro"/>
+                <a:cs typeface="Codec Pro"/>
+                <a:sym typeface="Codec Pro"/>
+              </a:rPr>
+              <a:t>inversores</a:t>
+            </a:r>
+            <a:r>
+              <a:rPr lang="en-US" sz="2799" u="none" spc="55" dirty="0">
+                <a:solidFill>
+                  <a:srgbClr val="000000"/>
+                </a:solidFill>
+                <a:latin typeface="Codec Pro"/>
+                <a:ea typeface="Codec Pro"/>
+                <a:cs typeface="Codec Pro"/>
+                <a:sym typeface="Codec Pro"/>
+              </a:rPr>
+              <a:t>, </a:t>
+            </a:r>
+            <a:r>
+              <a:rPr lang="en-US" sz="2799" u="none" spc="55" dirty="0" err="1">
+                <a:solidFill>
+                  <a:srgbClr val="000000"/>
+                </a:solidFill>
+                <a:latin typeface="Codec Pro"/>
+                <a:ea typeface="Codec Pro"/>
+                <a:cs typeface="Codec Pro"/>
+                <a:sym typeface="Codec Pro"/>
+              </a:rPr>
+              <a:t>desarrolladores</a:t>
+            </a:r>
+            <a:r>
+              <a:rPr lang="en-US" sz="2799" u="none" spc="55" dirty="0">
+                <a:solidFill>
+                  <a:srgbClr val="000000"/>
+                </a:solidFill>
+                <a:latin typeface="Codec Pro"/>
+                <a:ea typeface="Codec Pro"/>
+                <a:cs typeface="Codec Pro"/>
+                <a:sym typeface="Codec Pro"/>
+              </a:rPr>
+              <a:t> y </a:t>
+            </a:r>
+            <a:r>
+              <a:rPr lang="en-US" sz="2799" u="none" spc="55" dirty="0" err="1">
+                <a:solidFill>
+                  <a:srgbClr val="000000"/>
+                </a:solidFill>
+                <a:latin typeface="Codec Pro"/>
+                <a:ea typeface="Codec Pro"/>
+                <a:cs typeface="Codec Pro"/>
+                <a:sym typeface="Codec Pro"/>
+              </a:rPr>
+              <a:t>análisis</a:t>
+            </a:r>
+            <a:r>
+              <a:rPr lang="en-US" sz="2799" u="none" spc="55" dirty="0">
+                <a:solidFill>
+                  <a:srgbClr val="000000"/>
+                </a:solidFill>
+                <a:latin typeface="Codec Pro"/>
+                <a:ea typeface="Codec Pro"/>
+                <a:cs typeface="Codec Pro"/>
+                <a:sym typeface="Codec Pro"/>
+              </a:rPr>
+              <a:t> </a:t>
+            </a:r>
+            <a:r>
+              <a:rPr lang="en-US" sz="2799" u="none" spc="55" dirty="0" err="1">
+                <a:solidFill>
+                  <a:srgbClr val="000000"/>
+                </a:solidFill>
+                <a:latin typeface="Codec Pro"/>
+                <a:ea typeface="Codec Pro"/>
+                <a:cs typeface="Codec Pro"/>
+                <a:sym typeface="Codec Pro"/>
+              </a:rPr>
+              <a:t>urbano</a:t>
+            </a:r>
+            <a:r>
+              <a:rPr lang="en-US" sz="2799" u="none" spc="55" dirty="0">
+                <a:solidFill>
+                  <a:srgbClr val="000000"/>
+                </a:solidFill>
+                <a:latin typeface="Codec Pro"/>
+                <a:ea typeface="Codec Pro"/>
+                <a:cs typeface="Codec Pro"/>
+                <a:sym typeface="Codec Pro"/>
+              </a:rPr>
+              <a:t>.</a:t>
             </a:r>
           </a:p>
         </p:txBody>
@@ -4987,6 +5828,36 @@
           </a:p>
         </p:txBody>
       </p:sp>
+      <p:sp>
+        <p:nvSpPr>
+          <p:cNvPr id="7" name="Marcador de número de diapositiva 6">
+            <a:extLst>
+              <a:ext uri="{FF2B5EF4-FFF2-40B4-BE49-F238E27FC236}">
+                <a16:creationId xmlns:a16="http://schemas.microsoft.com/office/drawing/2014/main" id="{A159EAD6-FD8D-7FEE-4CB9-781FD0299B66}"/>
+              </a:ext>
+            </a:extLst>
+          </p:cNvPr>
+          <p:cNvSpPr>
+            <a:spLocks noGrp="1"/>
+          </p:cNvSpPr>
+          <p:nvPr>
+            <p:ph type="sldNum" sz="quarter" idx="12"/>
+          </p:nvPr>
+        </p:nvSpPr>
+        <p:spPr/>
+        <p:txBody>
+          <a:bodyPr/>
+          <a:lstStyle/>
+          <a:p>
+            <a:fld id="{B6F15528-21DE-4FAA-801E-634DDDAF4B2B}" type="slidenum">
+              <a:rPr lang="en-US" smtClean="0"/>
+              <a:pPr/>
+              <a:t>2</a:t>
+            </a:fld>
+            <a:endParaRPr lang="en-US"/>
+          </a:p>
+        </p:txBody>
+      </p:sp>
     </p:spTree>
   </p:cSld>
   <p:clrMapOvr>
@@ -4995,7 +5866,7 @@
 </p:sld>
 </file>
 
-<file path=ppt/slides/slide4.xml><?xml version="1.0" encoding="utf-8"?>
+<file path=ppt/slides/slide3.xml><?xml version="1.0" encoding="utf-8"?>
 <p:sld xmlns:a="http://schemas.openxmlformats.org/drawingml/2006/main" xmlns:r="http://schemas.openxmlformats.org/officeDocument/2006/relationships" xmlns:p="http://schemas.openxmlformats.org/presentationml/2006/main">
   <p:cSld>
     <p:spTree>
@@ -5110,8 +5981,8 @@
         </p:nvSpPr>
         <p:spPr>
           <a:xfrm>
-            <a:off x="732029" y="4293314"/>
-            <a:ext cx="17310674" cy="5066284"/>
+            <a:off x="685800" y="3679530"/>
+            <a:ext cx="17310674" cy="6656374"/>
           </a:xfrm>
           <a:prstGeom prst="rect">
             <a:avLst/>
@@ -5127,32 +5998,194 @@
               <a:lnSpc>
                 <a:spcPts val="3667"/>
               </a:lnSpc>
+              <a:spcBef>
+                <a:spcPts val="600"/>
+              </a:spcBef>
+              <a:spcAft>
+                <a:spcPts val="600"/>
+              </a:spcAft>
               <a:buFont typeface="Arial"/>
               <a:buChar char="•"/>
             </a:pPr>
             <a:r>
-              <a:rPr lang="en-US" sz="2799" spc="55">
-                <a:solidFill>
-                  <a:srgbClr val="000000"/>
-                </a:solidFill>
-                <a:latin typeface="Codec Pro"/>
-                <a:ea typeface="Codec Pro"/>
-                <a:cs typeface="Codec Pro"/>
-                <a:sym typeface="Codec Pro"/>
-              </a:rPr>
-              <a:t>Datos mensuales de </a:t>
-            </a:r>
-            <a:r>
-              <a:rPr lang="en-US" sz="2799" u="none" spc="55">
-                <a:solidFill>
-                  <a:srgbClr val="000000"/>
-                </a:solidFill>
-                <a:latin typeface="Codec Pro"/>
-                <a:ea typeface="Codec Pro"/>
-                <a:cs typeface="Codec Pro"/>
-                <a:sym typeface="Codec Pro"/>
-              </a:rPr>
-              <a:t>publicaciones de ZonaProp, último día hábil de cada mes.</a:t>
+              <a:rPr lang="en-US" sz="2799" spc="55" dirty="0">
+                <a:solidFill>
+                  <a:srgbClr val="000000"/>
+                </a:solidFill>
+                <a:latin typeface="Codec Pro"/>
+                <a:ea typeface="Codec Pro"/>
+                <a:cs typeface="Codec Pro"/>
+                <a:sym typeface="Codec Pro"/>
+              </a:rPr>
+              <a:t>Datos </a:t>
+            </a:r>
+            <a:r>
+              <a:rPr lang="en-US" sz="2799" spc="55" dirty="0" err="1">
+                <a:solidFill>
+                  <a:srgbClr val="000000"/>
+                </a:solidFill>
+                <a:latin typeface="Codec Pro"/>
+                <a:ea typeface="Codec Pro"/>
+                <a:cs typeface="Codec Pro"/>
+                <a:sym typeface="Codec Pro"/>
+              </a:rPr>
+              <a:t>mensuales</a:t>
+            </a:r>
+            <a:r>
+              <a:rPr lang="en-US" sz="2799" spc="55" dirty="0">
+                <a:solidFill>
+                  <a:srgbClr val="000000"/>
+                </a:solidFill>
+                <a:latin typeface="Codec Pro"/>
+                <a:ea typeface="Codec Pro"/>
+                <a:cs typeface="Codec Pro"/>
+                <a:sym typeface="Codec Pro"/>
+              </a:rPr>
+              <a:t> de </a:t>
+            </a:r>
+            <a:r>
+              <a:rPr lang="en-US" sz="2799" u="none" spc="55" dirty="0" err="1">
+                <a:solidFill>
+                  <a:srgbClr val="000000"/>
+                </a:solidFill>
+                <a:latin typeface="Codec Pro"/>
+                <a:ea typeface="Codec Pro"/>
+                <a:cs typeface="Codec Pro"/>
+                <a:sym typeface="Codec Pro"/>
+              </a:rPr>
+              <a:t>publicaciones</a:t>
+            </a:r>
+            <a:r>
+              <a:rPr lang="en-US" sz="2799" u="none" spc="55" dirty="0">
+                <a:solidFill>
+                  <a:srgbClr val="000000"/>
+                </a:solidFill>
+                <a:latin typeface="Codec Pro"/>
+                <a:ea typeface="Codec Pro"/>
+                <a:cs typeface="Codec Pro"/>
+                <a:sym typeface="Codec Pro"/>
+              </a:rPr>
+              <a:t> de </a:t>
+            </a:r>
+            <a:r>
+              <a:rPr lang="en-US" sz="2799" u="none" spc="55" dirty="0" err="1">
+                <a:solidFill>
+                  <a:srgbClr val="000000"/>
+                </a:solidFill>
+                <a:latin typeface="Codec Pro"/>
+                <a:ea typeface="Codec Pro"/>
+                <a:cs typeface="Codec Pro"/>
+                <a:sym typeface="Codec Pro"/>
+              </a:rPr>
+              <a:t>ZonaProp</a:t>
+            </a:r>
+            <a:r>
+              <a:rPr lang="en-US" sz="2799" u="none" spc="55" dirty="0">
+                <a:solidFill>
+                  <a:srgbClr val="000000"/>
+                </a:solidFill>
+                <a:latin typeface="Codec Pro"/>
+                <a:ea typeface="Codec Pro"/>
+                <a:cs typeface="Codec Pro"/>
+                <a:sym typeface="Codec Pro"/>
+              </a:rPr>
+              <a:t>, </a:t>
+            </a:r>
+            <a:r>
+              <a:rPr lang="en-US" sz="2799" u="none" spc="55" dirty="0" err="1">
+                <a:solidFill>
+                  <a:srgbClr val="000000"/>
+                </a:solidFill>
+                <a:latin typeface="Codec Pro"/>
+                <a:ea typeface="Codec Pro"/>
+                <a:cs typeface="Codec Pro"/>
+                <a:sym typeface="Codec Pro"/>
+              </a:rPr>
+              <a:t>último</a:t>
+            </a:r>
+            <a:r>
+              <a:rPr lang="en-US" sz="2799" u="none" spc="55" dirty="0">
+                <a:solidFill>
+                  <a:srgbClr val="000000"/>
+                </a:solidFill>
+                <a:latin typeface="Codec Pro"/>
+                <a:ea typeface="Codec Pro"/>
+                <a:cs typeface="Codec Pro"/>
+                <a:sym typeface="Codec Pro"/>
+              </a:rPr>
+              <a:t> día </a:t>
+            </a:r>
+            <a:r>
+              <a:rPr lang="en-US" sz="2799" u="none" spc="55" dirty="0" err="1">
+                <a:solidFill>
+                  <a:srgbClr val="000000"/>
+                </a:solidFill>
+                <a:latin typeface="Codec Pro"/>
+                <a:ea typeface="Codec Pro"/>
+                <a:cs typeface="Codec Pro"/>
+                <a:sym typeface="Codec Pro"/>
+              </a:rPr>
+              <a:t>hábil</a:t>
+            </a:r>
+            <a:r>
+              <a:rPr lang="en-US" sz="2799" u="none" spc="55" dirty="0">
+                <a:solidFill>
+                  <a:srgbClr val="000000"/>
+                </a:solidFill>
+                <a:latin typeface="Codec Pro"/>
+                <a:ea typeface="Codec Pro"/>
+                <a:cs typeface="Codec Pro"/>
+                <a:sym typeface="Codec Pro"/>
+              </a:rPr>
+              <a:t> de </a:t>
+            </a:r>
+            <a:r>
+              <a:rPr lang="en-US" sz="2799" u="none" spc="55" dirty="0" err="1">
+                <a:solidFill>
+                  <a:srgbClr val="000000"/>
+                </a:solidFill>
+                <a:latin typeface="Codec Pro"/>
+                <a:ea typeface="Codec Pro"/>
+                <a:cs typeface="Codec Pro"/>
+                <a:sym typeface="Codec Pro"/>
+              </a:rPr>
+              <a:t>cada</a:t>
+            </a:r>
+            <a:r>
+              <a:rPr lang="en-US" sz="2799" u="none" spc="55" dirty="0">
+                <a:solidFill>
+                  <a:srgbClr val="000000"/>
+                </a:solidFill>
+                <a:latin typeface="Codec Pro"/>
+                <a:ea typeface="Codec Pro"/>
+                <a:cs typeface="Codec Pro"/>
+                <a:sym typeface="Codec Pro"/>
+              </a:rPr>
+              <a:t> </a:t>
+            </a:r>
+            <a:r>
+              <a:rPr lang="en-US" sz="2799" u="none" spc="55" dirty="0" err="1">
+                <a:solidFill>
+                  <a:srgbClr val="000000"/>
+                </a:solidFill>
+                <a:latin typeface="Codec Pro"/>
+                <a:ea typeface="Codec Pro"/>
+                <a:cs typeface="Codec Pro"/>
+                <a:sym typeface="Codec Pro"/>
+              </a:rPr>
+              <a:t>mes</a:t>
+            </a:r>
+            <a:r>
+              <a:rPr lang="en-US" sz="2799" u="none" spc="55" dirty="0">
+                <a:solidFill>
+                  <a:srgbClr val="000000"/>
+                </a:solidFill>
+                <a:latin typeface="Codec Pro"/>
+                <a:ea typeface="Codec Pro"/>
+                <a:cs typeface="Codec Pro"/>
+                <a:sym typeface="Codec Pro"/>
+              </a:rPr>
+              <a:t>.</a:t>
             </a:r>
           </a:p>
           <a:p>
@@ -5160,20 +6193,62 @@
               <a:lnSpc>
                 <a:spcPts val="3667"/>
               </a:lnSpc>
+              <a:spcBef>
+                <a:spcPts val="600"/>
+              </a:spcBef>
+              <a:spcAft>
+                <a:spcPts val="600"/>
+              </a:spcAft>
               <a:buFont typeface="Arial"/>
               <a:buChar char="•"/>
             </a:pPr>
             <a:r>
-              <a:rPr lang="en-US" sz="2799" u="none" spc="55">
-                <a:solidFill>
-                  <a:srgbClr val="000000"/>
-                </a:solidFill>
-                <a:latin typeface="Codec Pro"/>
-                <a:ea typeface="Codec Pro"/>
-                <a:cs typeface="Codec Pro"/>
-                <a:sym typeface="Codec Pro"/>
-              </a:rPr>
-              <a:t>Período analizado: 2016–2025.</a:t>
+              <a:rPr lang="en-US" sz="2799" u="none" spc="55" dirty="0" err="1">
+                <a:solidFill>
+                  <a:srgbClr val="000000"/>
+                </a:solidFill>
+                <a:latin typeface="Codec Pro"/>
+                <a:ea typeface="Codec Pro"/>
+                <a:cs typeface="Codec Pro"/>
+                <a:sym typeface="Codec Pro"/>
+              </a:rPr>
+              <a:t>Período</a:t>
+            </a:r>
+            <a:r>
+              <a:rPr lang="en-US" sz="2799" u="none" spc="55" dirty="0">
+                <a:solidFill>
+                  <a:srgbClr val="000000"/>
+                </a:solidFill>
+                <a:latin typeface="Codec Pro"/>
+                <a:ea typeface="Codec Pro"/>
+                <a:cs typeface="Codec Pro"/>
+                <a:sym typeface="Codec Pro"/>
+              </a:rPr>
+              <a:t> </a:t>
+            </a:r>
+            <a:r>
+              <a:rPr lang="en-US" sz="2799" u="none" spc="55" dirty="0" err="1">
+                <a:solidFill>
+                  <a:srgbClr val="000000"/>
+                </a:solidFill>
+                <a:latin typeface="Codec Pro"/>
+                <a:ea typeface="Codec Pro"/>
+                <a:cs typeface="Codec Pro"/>
+                <a:sym typeface="Codec Pro"/>
+              </a:rPr>
+              <a:t>analizado</a:t>
+            </a:r>
+            <a:r>
+              <a:rPr lang="en-US" sz="2799" u="none" spc="55" dirty="0">
+                <a:solidFill>
+                  <a:srgbClr val="000000"/>
+                </a:solidFill>
+                <a:latin typeface="Codec Pro"/>
+                <a:ea typeface="Codec Pro"/>
+                <a:cs typeface="Codec Pro"/>
+                <a:sym typeface="Codec Pro"/>
+              </a:rPr>
+              <a:t>: 2016–2025.</a:t>
             </a:r>
           </a:p>
           <a:p>
@@ -5181,20 +6256,86 @@
               <a:lnSpc>
                 <a:spcPts val="3667"/>
               </a:lnSpc>
+              <a:spcBef>
+                <a:spcPts val="600"/>
+              </a:spcBef>
+              <a:spcAft>
+                <a:spcPts val="600"/>
+              </a:spcAft>
               <a:buFont typeface="Arial"/>
               <a:buChar char="•"/>
             </a:pPr>
             <a:r>
-              <a:rPr lang="en-US" sz="2799" u="none" spc="55">
-                <a:solidFill>
-                  <a:srgbClr val="000000"/>
-                </a:solidFill>
-                <a:latin typeface="Codec Pro"/>
-                <a:ea typeface="Codec Pro"/>
-                <a:cs typeface="Codec Pro"/>
-                <a:sym typeface="Codec Pro"/>
-              </a:rPr>
-              <a:t>Observaciones: departamentos, casas, PH, oficinas, etc.</a:t>
+              <a:rPr lang="en-US" sz="2799" u="none" spc="55" dirty="0" err="1">
+                <a:solidFill>
+                  <a:srgbClr val="000000"/>
+                </a:solidFill>
+                <a:latin typeface="Codec Pro"/>
+                <a:ea typeface="Codec Pro"/>
+                <a:cs typeface="Codec Pro"/>
+                <a:sym typeface="Codec Pro"/>
+              </a:rPr>
+              <a:t>Observaciones</a:t>
+            </a:r>
+            <a:r>
+              <a:rPr lang="en-US" sz="2799" u="none" spc="55" dirty="0">
+                <a:solidFill>
+                  <a:srgbClr val="000000"/>
+                </a:solidFill>
+                <a:latin typeface="Codec Pro"/>
+                <a:ea typeface="Codec Pro"/>
+                <a:cs typeface="Codec Pro"/>
+                <a:sym typeface="Codec Pro"/>
+              </a:rPr>
+              <a:t>: </a:t>
+            </a:r>
+            <a:r>
+              <a:rPr lang="en-US" sz="2799" u="none" spc="55" dirty="0" err="1">
+                <a:solidFill>
+                  <a:srgbClr val="000000"/>
+                </a:solidFill>
+                <a:latin typeface="Codec Pro"/>
+                <a:ea typeface="Codec Pro"/>
+                <a:cs typeface="Codec Pro"/>
+                <a:sym typeface="Codec Pro"/>
+              </a:rPr>
+              <a:t>departamentos</a:t>
+            </a:r>
+            <a:r>
+              <a:rPr lang="en-US" sz="2799" u="none" spc="55" dirty="0">
+                <a:solidFill>
+                  <a:srgbClr val="000000"/>
+                </a:solidFill>
+                <a:latin typeface="Codec Pro"/>
+                <a:ea typeface="Codec Pro"/>
+                <a:cs typeface="Codec Pro"/>
+                <a:sym typeface="Codec Pro"/>
+              </a:rPr>
+              <a:t>, casas, PH, </a:t>
+            </a:r>
+            <a:r>
+              <a:rPr lang="en-US" sz="2799" u="none" spc="55" dirty="0" err="1">
+                <a:solidFill>
+                  <a:srgbClr val="000000"/>
+                </a:solidFill>
+                <a:latin typeface="Codec Pro"/>
+                <a:ea typeface="Codec Pro"/>
+                <a:cs typeface="Codec Pro"/>
+                <a:sym typeface="Codec Pro"/>
+              </a:rPr>
+              <a:t>oficinas</a:t>
+            </a:r>
+            <a:r>
+              <a:rPr lang="en-US" sz="2799" u="none" spc="55" dirty="0">
+                <a:solidFill>
+                  <a:srgbClr val="000000"/>
+                </a:solidFill>
+                <a:latin typeface="Codec Pro"/>
+                <a:ea typeface="Codec Pro"/>
+                <a:cs typeface="Codec Pro"/>
+                <a:sym typeface="Codec Pro"/>
+              </a:rPr>
+              <a:t>, etc.</a:t>
             </a:r>
           </a:p>
           <a:p>
@@ -5202,20 +6343,419 @@
               <a:lnSpc>
                 <a:spcPts val="3667"/>
               </a:lnSpc>
+              <a:spcBef>
+                <a:spcPts val="600"/>
+              </a:spcBef>
+              <a:spcAft>
+                <a:spcPts val="600"/>
+              </a:spcAft>
               <a:buFont typeface="Arial"/>
               <a:buChar char="•"/>
             </a:pPr>
             <a:r>
-              <a:rPr lang="en-US" sz="2799" u="none" spc="55">
-                <a:solidFill>
-                  <a:srgbClr val="000000"/>
-                </a:solidFill>
-                <a:latin typeface="Codec Pro"/>
-                <a:ea typeface="Codec Pro"/>
-                <a:cs typeface="Codec Pro"/>
-                <a:sym typeface="Codec Pro"/>
-              </a:rPr>
-              <a:t>Variables principales:</a:t>
+              <a:rPr lang="en-US" sz="2799" u="none" spc="55" dirty="0">
+                <a:solidFill>
+                  <a:srgbClr val="000000"/>
+                </a:solidFill>
+                <a:latin typeface="Codec Pro"/>
+                <a:ea typeface="Codec Pro"/>
+                <a:cs typeface="Codec Pro"/>
+                <a:sym typeface="Codec Pro"/>
+              </a:rPr>
+              <a:t>Variables </a:t>
+            </a:r>
+            <a:r>
+              <a:rPr lang="en-US" sz="2799" u="none" spc="55" dirty="0" err="1">
+                <a:solidFill>
+                  <a:srgbClr val="000000"/>
+                </a:solidFill>
+                <a:latin typeface="Codec Pro"/>
+                <a:ea typeface="Codec Pro"/>
+                <a:cs typeface="Codec Pro"/>
+                <a:sym typeface="Codec Pro"/>
+              </a:rPr>
+              <a:t>principales</a:t>
+            </a:r>
+            <a:r>
+              <a:rPr lang="en-US" sz="2799" u="none" spc="55" dirty="0">
+                <a:solidFill>
+                  <a:srgbClr val="000000"/>
+                </a:solidFill>
+                <a:latin typeface="Codec Pro"/>
+                <a:ea typeface="Codec Pro"/>
+                <a:cs typeface="Codec Pro"/>
+                <a:sym typeface="Codec Pro"/>
+              </a:rPr>
+              <a:t>:</a:t>
+            </a:r>
+          </a:p>
+          <a:p>
+            <a:pPr marL="1216658" lvl="2" indent="-457200" algn="just">
+              <a:lnSpc>
+                <a:spcPts val="3667"/>
+              </a:lnSpc>
+              <a:spcBef>
+                <a:spcPts val="600"/>
+              </a:spcBef>
+              <a:spcAft>
+                <a:spcPts val="600"/>
+              </a:spcAft>
+              <a:buFont typeface="Wingdings" panose="05000000000000000000" pitchFamily="2" charset="2"/>
+              <a:buChar char="Ø"/>
+            </a:pPr>
+            <a:r>
+              <a:rPr lang="en-US" sz="2799" u="none" spc="55" dirty="0" err="1">
+                <a:solidFill>
+                  <a:srgbClr val="000000"/>
+                </a:solidFill>
+                <a:latin typeface="Codec Pro"/>
+                <a:ea typeface="Codec Pro"/>
+                <a:cs typeface="Codec Pro"/>
+                <a:sym typeface="Codec Pro"/>
+              </a:rPr>
+              <a:t>Precio</a:t>
+            </a:r>
+            <a:r>
+              <a:rPr lang="en-US" sz="2799" u="none" spc="55" dirty="0">
+                <a:solidFill>
+                  <a:srgbClr val="000000"/>
+                </a:solidFill>
+                <a:latin typeface="Codec Pro"/>
+                <a:ea typeface="Codec Pro"/>
+                <a:cs typeface="Codec Pro"/>
+                <a:sym typeface="Codec Pro"/>
+              </a:rPr>
+              <a:t> (</a:t>
+            </a:r>
+            <a:r>
+              <a:rPr lang="en-US" sz="2799" u="none" spc="55" dirty="0" err="1">
+                <a:solidFill>
+                  <a:srgbClr val="000000"/>
+                </a:solidFill>
+                <a:latin typeface="Codec Pro"/>
+                <a:ea typeface="Codec Pro"/>
+                <a:cs typeface="Codec Pro"/>
+                <a:sym typeface="Codec Pro"/>
+              </a:rPr>
+              <a:t>MontoOperacion</a:t>
+            </a:r>
+            <a:r>
+              <a:rPr lang="en-US" sz="2799" u="none" spc="55" dirty="0">
+                <a:solidFill>
+                  <a:srgbClr val="000000"/>
+                </a:solidFill>
+                <a:latin typeface="Codec Pro"/>
+                <a:ea typeface="Codec Pro"/>
+                <a:cs typeface="Codec Pro"/>
+                <a:sym typeface="Codec Pro"/>
+              </a:rPr>
+              <a:t>)</a:t>
+            </a:r>
+          </a:p>
+          <a:p>
+            <a:pPr marL="1216658" lvl="2" indent="-457200" algn="just">
+              <a:lnSpc>
+                <a:spcPts val="3667"/>
+              </a:lnSpc>
+              <a:spcBef>
+                <a:spcPts val="600"/>
+              </a:spcBef>
+              <a:spcAft>
+                <a:spcPts val="600"/>
+              </a:spcAft>
+              <a:buFont typeface="Wingdings" panose="05000000000000000000" pitchFamily="2" charset="2"/>
+              <a:buChar char="Ø"/>
+            </a:pPr>
+            <a:r>
+              <a:rPr lang="en-US" sz="2799" u="none" spc="55" dirty="0" err="1">
+                <a:solidFill>
+                  <a:srgbClr val="000000"/>
+                </a:solidFill>
+                <a:latin typeface="Codec Pro"/>
+                <a:ea typeface="Codec Pro"/>
+                <a:cs typeface="Codec Pro"/>
+                <a:sym typeface="Codec Pro"/>
+              </a:rPr>
+              <a:t>Superficie</a:t>
+            </a:r>
+            <a:r>
+              <a:rPr lang="en-US" sz="2799" u="none" spc="55" dirty="0">
+                <a:solidFill>
+                  <a:srgbClr val="000000"/>
+                </a:solidFill>
+                <a:latin typeface="Codec Pro"/>
+                <a:ea typeface="Codec Pro"/>
+                <a:cs typeface="Codec Pro"/>
+                <a:sym typeface="Codec Pro"/>
+              </a:rPr>
+              <a:t> total / </a:t>
+            </a:r>
+            <a:r>
+              <a:rPr lang="en-US" sz="2799" u="none" spc="55" dirty="0" err="1">
+                <a:solidFill>
+                  <a:srgbClr val="000000"/>
+                </a:solidFill>
+                <a:latin typeface="Codec Pro"/>
+                <a:ea typeface="Codec Pro"/>
+                <a:cs typeface="Codec Pro"/>
+                <a:sym typeface="Codec Pro"/>
+              </a:rPr>
+              <a:t>cubierta</a:t>
+            </a:r>
+            <a:r>
+              <a:rPr lang="en-US" sz="2799" u="none" spc="55" dirty="0">
+                <a:solidFill>
+                  <a:srgbClr val="000000"/>
+                </a:solidFill>
+                <a:latin typeface="Codec Pro"/>
+                <a:ea typeface="Codec Pro"/>
+                <a:cs typeface="Codec Pro"/>
+                <a:sym typeface="Codec Pro"/>
+              </a:rPr>
+              <a:t> / </a:t>
+            </a:r>
+            <a:r>
+              <a:rPr lang="en-US" sz="2799" u="none" spc="55" dirty="0" err="1">
+                <a:solidFill>
+                  <a:srgbClr val="000000"/>
+                </a:solidFill>
+                <a:latin typeface="Codec Pro"/>
+                <a:ea typeface="Codec Pro"/>
+                <a:cs typeface="Codec Pro"/>
+                <a:sym typeface="Codec Pro"/>
+              </a:rPr>
+              <a:t>descubierta</a:t>
+            </a:r>
+            <a:endParaRPr lang="en-US" sz="2799" u="none" spc="55" dirty="0">
+              <a:solidFill>
+                <a:srgbClr val="000000"/>
+              </a:solidFill>
+              <a:latin typeface="Codec Pro"/>
+              <a:ea typeface="Codec Pro"/>
+              <a:cs typeface="Codec Pro"/>
+              <a:sym typeface="Codec Pro"/>
+            </a:endParaRPr>
+          </a:p>
+          <a:p>
+            <a:pPr marL="1216658" lvl="2" indent="-457200" algn="just">
+              <a:lnSpc>
+                <a:spcPts val="3667"/>
+              </a:lnSpc>
+              <a:spcBef>
+                <a:spcPts val="600"/>
+              </a:spcBef>
+              <a:spcAft>
+                <a:spcPts val="600"/>
+              </a:spcAft>
+              <a:buFont typeface="Wingdings" panose="05000000000000000000" pitchFamily="2" charset="2"/>
+              <a:buChar char="Ø"/>
+            </a:pPr>
+            <a:r>
+              <a:rPr lang="en-US" sz="2799" u="none" spc="55" dirty="0" err="1">
+                <a:solidFill>
+                  <a:srgbClr val="000000"/>
+                </a:solidFill>
+                <a:latin typeface="Codec Pro"/>
+                <a:ea typeface="Codec Pro"/>
+                <a:cs typeface="Codec Pro"/>
+                <a:sym typeface="Codec Pro"/>
+              </a:rPr>
+              <a:t>Ubicación</a:t>
+            </a:r>
+            <a:r>
+              <a:rPr lang="en-US" sz="2799" u="none" spc="55" dirty="0">
+                <a:solidFill>
+                  <a:srgbClr val="000000"/>
+                </a:solidFill>
+                <a:latin typeface="Codec Pro"/>
+                <a:ea typeface="Codec Pro"/>
+                <a:cs typeface="Codec Pro"/>
+                <a:sym typeface="Codec Pro"/>
+              </a:rPr>
+              <a:t> (Provincia, </a:t>
+            </a:r>
+            <a:r>
+              <a:rPr lang="en-US" sz="2799" u="none" spc="55" dirty="0" err="1">
+                <a:solidFill>
+                  <a:srgbClr val="000000"/>
+                </a:solidFill>
+                <a:latin typeface="Codec Pro"/>
+                <a:ea typeface="Codec Pro"/>
+                <a:cs typeface="Codec Pro"/>
+                <a:sym typeface="Codec Pro"/>
+              </a:rPr>
+              <a:t>Localidad</a:t>
+            </a:r>
+            <a:r>
+              <a:rPr lang="en-US" sz="2799" u="none" spc="55" dirty="0">
+                <a:solidFill>
+                  <a:srgbClr val="000000"/>
+                </a:solidFill>
+                <a:latin typeface="Codec Pro"/>
+                <a:ea typeface="Codec Pro"/>
+                <a:cs typeface="Codec Pro"/>
+                <a:sym typeface="Codec Pro"/>
+              </a:rPr>
+              <a:t>, Barrio, </a:t>
+            </a:r>
+            <a:r>
+              <a:rPr lang="en-US" sz="2799" u="none" spc="55" dirty="0" err="1">
+                <a:solidFill>
+                  <a:srgbClr val="000000"/>
+                </a:solidFill>
+                <a:latin typeface="Codec Pro"/>
+                <a:ea typeface="Codec Pro"/>
+                <a:cs typeface="Codec Pro"/>
+                <a:sym typeface="Codec Pro"/>
+              </a:rPr>
+              <a:t>coordenadas</a:t>
+            </a:r>
+            <a:r>
+              <a:rPr lang="en-US" sz="2799" u="none" spc="55" dirty="0">
+                <a:solidFill>
+                  <a:srgbClr val="000000"/>
+                </a:solidFill>
+                <a:latin typeface="Codec Pro"/>
+                <a:ea typeface="Codec Pro"/>
+                <a:cs typeface="Codec Pro"/>
+                <a:sym typeface="Codec Pro"/>
+              </a:rPr>
+              <a:t>)</a:t>
+            </a:r>
+          </a:p>
+          <a:p>
+            <a:pPr marL="1216658" lvl="2" indent="-457200" algn="just">
+              <a:lnSpc>
+                <a:spcPts val="3667"/>
+              </a:lnSpc>
+              <a:spcBef>
+                <a:spcPts val="600"/>
+              </a:spcBef>
+              <a:spcAft>
+                <a:spcPts val="600"/>
+              </a:spcAft>
+              <a:buFont typeface="Wingdings" panose="05000000000000000000" pitchFamily="2" charset="2"/>
+              <a:buChar char="Ø"/>
+            </a:pPr>
+            <a:r>
+              <a:rPr lang="en-US" sz="2799" u="none" spc="55" dirty="0" err="1">
+                <a:solidFill>
+                  <a:srgbClr val="000000"/>
+                </a:solidFill>
+                <a:latin typeface="Codec Pro"/>
+                <a:ea typeface="Codec Pro"/>
+                <a:cs typeface="Codec Pro"/>
+                <a:sym typeface="Codec Pro"/>
+              </a:rPr>
+              <a:t>Características</a:t>
+            </a:r>
+            <a:r>
+              <a:rPr lang="en-US" sz="2799" u="none" spc="55" dirty="0">
+                <a:solidFill>
+                  <a:srgbClr val="000000"/>
+                </a:solidFill>
+                <a:latin typeface="Codec Pro"/>
+                <a:ea typeface="Codec Pro"/>
+                <a:cs typeface="Codec Pro"/>
+                <a:sym typeface="Codec Pro"/>
+              </a:rPr>
+              <a:t> (ambientes, </a:t>
+            </a:r>
+            <a:r>
+              <a:rPr lang="en-US" sz="2799" u="none" spc="55" dirty="0" err="1">
+                <a:solidFill>
+                  <a:srgbClr val="000000"/>
+                </a:solidFill>
+                <a:latin typeface="Codec Pro"/>
+                <a:ea typeface="Codec Pro"/>
+                <a:cs typeface="Codec Pro"/>
+                <a:sym typeface="Codec Pro"/>
+              </a:rPr>
+              <a:t>dormitorios</a:t>
+            </a:r>
+            <a:r>
+              <a:rPr lang="en-US" sz="2799" u="none" spc="55" dirty="0">
+                <a:solidFill>
+                  <a:srgbClr val="000000"/>
+                </a:solidFill>
+                <a:latin typeface="Codec Pro"/>
+                <a:ea typeface="Codec Pro"/>
+                <a:cs typeface="Codec Pro"/>
+                <a:sym typeface="Codec Pro"/>
+              </a:rPr>
+              <a:t>, </a:t>
+            </a:r>
+            <a:r>
+              <a:rPr lang="en-US" sz="2799" u="none" spc="55" dirty="0" err="1">
+                <a:solidFill>
+                  <a:srgbClr val="000000"/>
+                </a:solidFill>
+                <a:latin typeface="Codec Pro"/>
+                <a:ea typeface="Codec Pro"/>
+                <a:cs typeface="Codec Pro"/>
+                <a:sym typeface="Codec Pro"/>
+              </a:rPr>
+              <a:t>cocheras</a:t>
+            </a:r>
+            <a:r>
+              <a:rPr lang="en-US" sz="2799" u="none" spc="55" dirty="0">
+                <a:solidFill>
+                  <a:srgbClr val="000000"/>
+                </a:solidFill>
+                <a:latin typeface="Codec Pro"/>
+                <a:ea typeface="Codec Pro"/>
+                <a:cs typeface="Codec Pro"/>
+                <a:sym typeface="Codec Pro"/>
+              </a:rPr>
+              <a:t>, </a:t>
+            </a:r>
+            <a:r>
+              <a:rPr lang="en-US" sz="2799" u="none" spc="55" dirty="0" err="1">
+                <a:solidFill>
+                  <a:srgbClr val="000000"/>
+                </a:solidFill>
+                <a:latin typeface="Codec Pro"/>
+                <a:ea typeface="Codec Pro"/>
+                <a:cs typeface="Codec Pro"/>
+                <a:sym typeface="Codec Pro"/>
+              </a:rPr>
+              <a:t>antigüedad</a:t>
+            </a:r>
+            <a:r>
+              <a:rPr lang="en-US" sz="2799" u="none" spc="55" dirty="0">
+                <a:solidFill>
+                  <a:srgbClr val="000000"/>
+                </a:solidFill>
+                <a:latin typeface="Codec Pro"/>
+                <a:ea typeface="Codec Pro"/>
+                <a:cs typeface="Codec Pro"/>
+                <a:sym typeface="Codec Pro"/>
+              </a:rPr>
+              <a:t>, </a:t>
+            </a:r>
+            <a:r>
+              <a:rPr lang="en-US" sz="2799" u="none" spc="55" dirty="0" err="1">
+                <a:solidFill>
+                  <a:srgbClr val="000000"/>
+                </a:solidFill>
+                <a:latin typeface="Codec Pro"/>
+                <a:ea typeface="Codec Pro"/>
+                <a:cs typeface="Codec Pro"/>
+                <a:sym typeface="Codec Pro"/>
+              </a:rPr>
+              <a:t>expensas</a:t>
+            </a:r>
+            <a:r>
+              <a:rPr lang="en-US" sz="2799" u="none" spc="55" dirty="0">
+                <a:solidFill>
+                  <a:srgbClr val="000000"/>
+                </a:solidFill>
+                <a:latin typeface="Codec Pro"/>
+                <a:ea typeface="Codec Pro"/>
+                <a:cs typeface="Codec Pro"/>
+                <a:sym typeface="Codec Pro"/>
+              </a:rPr>
+              <a:t>)</a:t>
             </a:r>
           </a:p>
           <a:p>
@@ -5223,20 +6763,146 @@
               <a:lnSpc>
                 <a:spcPts val="3667"/>
               </a:lnSpc>
+              <a:spcBef>
+                <a:spcPts val="600"/>
+              </a:spcBef>
+              <a:spcAft>
+                <a:spcPts val="600"/>
+              </a:spcAft>
               <a:buFont typeface="Arial"/>
               <a:buChar char="•"/>
             </a:pPr>
             <a:r>
-              <a:rPr lang="en-US" sz="2799" u="none" spc="55">
-                <a:solidFill>
-                  <a:srgbClr val="000000"/>
-                </a:solidFill>
-                <a:latin typeface="Codec Pro"/>
-                <a:ea typeface="Codec Pro"/>
-                <a:cs typeface="Codec Pro"/>
-                <a:sym typeface="Codec Pro"/>
-              </a:rPr>
-              <a:t>Precio (MontoOperacion)</a:t>
+              <a:rPr lang="en-US" sz="2799" u="none" spc="55" dirty="0">
+                <a:solidFill>
+                  <a:srgbClr val="000000"/>
+                </a:solidFill>
+                <a:latin typeface="Codec Pro"/>
+                <a:ea typeface="Codec Pro"/>
+                <a:cs typeface="Codec Pro"/>
+                <a:sym typeface="Codec Pro"/>
+              </a:rPr>
+              <a:t>Se </a:t>
+            </a:r>
+            <a:r>
+              <a:rPr lang="en-US" sz="2799" u="none" spc="55" dirty="0" err="1">
+                <a:solidFill>
+                  <a:srgbClr val="000000"/>
+                </a:solidFill>
+                <a:latin typeface="Codec Pro"/>
+                <a:ea typeface="Codec Pro"/>
+                <a:cs typeface="Codec Pro"/>
+                <a:sym typeface="Codec Pro"/>
+              </a:rPr>
+              <a:t>combinan</a:t>
+            </a:r>
+            <a:r>
+              <a:rPr lang="en-US" sz="2799" u="none" spc="55" dirty="0">
+                <a:solidFill>
+                  <a:srgbClr val="000000"/>
+                </a:solidFill>
+                <a:latin typeface="Codec Pro"/>
+                <a:ea typeface="Codec Pro"/>
+                <a:cs typeface="Codec Pro"/>
+                <a:sym typeface="Codec Pro"/>
+              </a:rPr>
+              <a:t> </a:t>
+            </a:r>
+            <a:r>
+              <a:rPr lang="en-US" sz="2799" u="none" spc="55" dirty="0" err="1">
+                <a:solidFill>
+                  <a:srgbClr val="000000"/>
+                </a:solidFill>
+                <a:latin typeface="Codec Pro"/>
+                <a:ea typeface="Codec Pro"/>
+                <a:cs typeface="Codec Pro"/>
+                <a:sym typeface="Codec Pro"/>
+              </a:rPr>
+              <a:t>todas</a:t>
+            </a:r>
+            <a:r>
+              <a:rPr lang="en-US" sz="2799" u="none" spc="55" dirty="0">
+                <a:solidFill>
+                  <a:srgbClr val="000000"/>
+                </a:solidFill>
+                <a:latin typeface="Codec Pro"/>
+                <a:ea typeface="Codec Pro"/>
+                <a:cs typeface="Codec Pro"/>
+                <a:sym typeface="Codec Pro"/>
+              </a:rPr>
+              <a:t> las bases </a:t>
+            </a:r>
+            <a:r>
+              <a:rPr lang="en-US" sz="2799" u="none" spc="55" dirty="0" err="1">
+                <a:solidFill>
+                  <a:srgbClr val="000000"/>
+                </a:solidFill>
+                <a:latin typeface="Codec Pro"/>
+                <a:ea typeface="Codec Pro"/>
+                <a:cs typeface="Codec Pro"/>
+                <a:sym typeface="Codec Pro"/>
+              </a:rPr>
+              <a:t>en</a:t>
+            </a:r>
+            <a:r>
+              <a:rPr lang="en-US" sz="2799" u="none" spc="55" dirty="0">
+                <a:solidFill>
+                  <a:srgbClr val="000000"/>
+                </a:solidFill>
+                <a:latin typeface="Codec Pro"/>
+                <a:ea typeface="Codec Pro"/>
+                <a:cs typeface="Codec Pro"/>
+                <a:sym typeface="Codec Pro"/>
+              </a:rPr>
+              <a:t> un </a:t>
+            </a:r>
+            <a:r>
+              <a:rPr lang="en-US" sz="2799" u="none" spc="55" dirty="0" err="1">
+                <a:solidFill>
+                  <a:srgbClr val="000000"/>
+                </a:solidFill>
+                <a:latin typeface="Codec Pro"/>
+                <a:ea typeface="Codec Pro"/>
+                <a:cs typeface="Codec Pro"/>
+                <a:sym typeface="Codec Pro"/>
+              </a:rPr>
+              <a:t>único</a:t>
+            </a:r>
+            <a:r>
+              <a:rPr lang="en-US" sz="2799" u="none" spc="55" dirty="0">
+                <a:solidFill>
+                  <a:srgbClr val="000000"/>
+                </a:solidFill>
+                <a:latin typeface="Codec Pro"/>
+                <a:ea typeface="Codec Pro"/>
+                <a:cs typeface="Codec Pro"/>
+                <a:sym typeface="Codec Pro"/>
+              </a:rPr>
+              <a:t> panel </a:t>
+            </a:r>
+            <a:r>
+              <a:rPr lang="en-US" sz="2799" u="none" spc="55" dirty="0" err="1">
+                <a:solidFill>
+                  <a:srgbClr val="000000"/>
+                </a:solidFill>
+                <a:latin typeface="Codec Pro"/>
+                <a:ea typeface="Codec Pro"/>
+                <a:cs typeface="Codec Pro"/>
+                <a:sym typeface="Codec Pro"/>
+              </a:rPr>
+              <a:t>mensual</a:t>
+            </a:r>
+            <a:r>
+              <a:rPr lang="en-US" sz="2799" u="none" spc="55" dirty="0">
+                <a:solidFill>
+                  <a:srgbClr val="000000"/>
+                </a:solidFill>
+                <a:latin typeface="Codec Pro"/>
+                <a:ea typeface="Codec Pro"/>
+                <a:cs typeface="Codec Pro"/>
+                <a:sym typeface="Codec Pro"/>
+              </a:rPr>
+              <a:t>.</a:t>
             </a:r>
           </a:p>
           <a:p>
@@ -5244,104 +6910,158 @@
               <a:lnSpc>
                 <a:spcPts val="3667"/>
               </a:lnSpc>
+              <a:spcBef>
+                <a:spcPts val="600"/>
+              </a:spcBef>
+              <a:spcAft>
+                <a:spcPts val="600"/>
+              </a:spcAft>
               <a:buFont typeface="Arial"/>
               <a:buChar char="•"/>
             </a:pPr>
             <a:r>
-              <a:rPr lang="en-US" sz="2799" u="none" spc="55">
-                <a:solidFill>
-                  <a:srgbClr val="000000"/>
-                </a:solidFill>
-                <a:latin typeface="Codec Pro"/>
-                <a:ea typeface="Codec Pro"/>
-                <a:cs typeface="Codec Pro"/>
-                <a:sym typeface="Codec Pro"/>
-              </a:rPr>
-              <a:t>Superficie total / cubierta / descubierta</a:t>
-            </a:r>
-          </a:p>
-          <a:p>
-            <a:pPr marL="604516" lvl="1" indent="-302258" algn="just">
-              <a:lnSpc>
-                <a:spcPts val="3667"/>
-              </a:lnSpc>
-              <a:buFont typeface="Arial"/>
-              <a:buChar char="•"/>
-            </a:pPr>
-            <a:r>
-              <a:rPr lang="en-US" sz="2799" u="none" spc="55">
-                <a:solidFill>
-                  <a:srgbClr val="000000"/>
-                </a:solidFill>
-                <a:latin typeface="Codec Pro"/>
-                <a:ea typeface="Codec Pro"/>
-                <a:cs typeface="Codec Pro"/>
-                <a:sym typeface="Codec Pro"/>
-              </a:rPr>
-              <a:t>Ubicación (Provincia, Localidad, Barrio, coordenadas)</a:t>
-            </a:r>
-          </a:p>
-          <a:p>
-            <a:pPr marL="604516" lvl="1" indent="-302258" algn="just">
-              <a:lnSpc>
-                <a:spcPts val="3667"/>
-              </a:lnSpc>
-              <a:buFont typeface="Arial"/>
-              <a:buChar char="•"/>
-            </a:pPr>
-            <a:r>
-              <a:rPr lang="en-US" sz="2799" u="none" spc="55">
-                <a:solidFill>
-                  <a:srgbClr val="000000"/>
-                </a:solidFill>
-                <a:latin typeface="Codec Pro"/>
-                <a:ea typeface="Codec Pro"/>
-                <a:cs typeface="Codec Pro"/>
-                <a:sym typeface="Codec Pro"/>
-              </a:rPr>
-              <a:t>Características (ambientes, dormitorios, cocheras, antigüedad, expensas)</a:t>
-            </a:r>
-          </a:p>
-          <a:p>
-            <a:pPr marL="604516" lvl="1" indent="-302258" algn="just">
-              <a:lnSpc>
-                <a:spcPts val="3667"/>
-              </a:lnSpc>
-              <a:buFont typeface="Arial"/>
-              <a:buChar char="•"/>
-            </a:pPr>
-            <a:r>
-              <a:rPr lang="en-US" sz="2799" u="none" spc="55">
-                <a:solidFill>
-                  <a:srgbClr val="000000"/>
-                </a:solidFill>
-                <a:latin typeface="Codec Pro"/>
-                <a:ea typeface="Codec Pro"/>
-                <a:cs typeface="Codec Pro"/>
-                <a:sym typeface="Codec Pro"/>
-              </a:rPr>
-              <a:t>Se combinan todas las bases en un único panel mensual.</a:t>
-            </a:r>
-          </a:p>
-          <a:p>
-            <a:pPr marL="604516" lvl="1" indent="-302258" algn="just">
-              <a:lnSpc>
-                <a:spcPts val="3667"/>
-              </a:lnSpc>
-              <a:buFont typeface="Arial"/>
-              <a:buChar char="•"/>
-            </a:pPr>
-            <a:r>
-              <a:rPr lang="en-US" sz="2799" u="none" spc="55">
-                <a:solidFill>
-                  <a:srgbClr val="000000"/>
-                </a:solidFill>
-                <a:latin typeface="Codec Pro"/>
-                <a:ea typeface="Codec Pro"/>
-                <a:cs typeface="Codec Pro"/>
-                <a:sym typeface="Codec Pro"/>
-              </a:rPr>
-              <a:t>Limpieza: tratamiento de outliers, duplicados, diferencias de formato y georreferencias.</a:t>
+              <a:rPr lang="en-US" sz="2799" u="none" spc="55" dirty="0" err="1">
+                <a:solidFill>
+                  <a:srgbClr val="000000"/>
+                </a:solidFill>
+                <a:latin typeface="Codec Pro"/>
+                <a:ea typeface="Codec Pro"/>
+                <a:cs typeface="Codec Pro"/>
+                <a:sym typeface="Codec Pro"/>
+              </a:rPr>
+              <a:t>Limpieza</a:t>
+            </a:r>
+            <a:r>
+              <a:rPr lang="en-US" sz="2799" u="none" spc="55" dirty="0">
+                <a:solidFill>
+                  <a:srgbClr val="000000"/>
+                </a:solidFill>
+                <a:latin typeface="Codec Pro"/>
+                <a:ea typeface="Codec Pro"/>
+                <a:cs typeface="Codec Pro"/>
+                <a:sym typeface="Codec Pro"/>
+              </a:rPr>
+              <a:t>: </a:t>
+            </a:r>
+            <a:r>
+              <a:rPr lang="en-US" sz="2799" u="none" spc="55" dirty="0" err="1">
+                <a:solidFill>
+                  <a:srgbClr val="000000"/>
+                </a:solidFill>
+                <a:latin typeface="Codec Pro"/>
+                <a:ea typeface="Codec Pro"/>
+                <a:cs typeface="Codec Pro"/>
+                <a:sym typeface="Codec Pro"/>
+              </a:rPr>
+              <a:t>tratamiento</a:t>
+            </a:r>
+            <a:r>
+              <a:rPr lang="en-US" sz="2799" u="none" spc="55" dirty="0">
+                <a:solidFill>
+                  <a:srgbClr val="000000"/>
+                </a:solidFill>
+                <a:latin typeface="Codec Pro"/>
+                <a:ea typeface="Codec Pro"/>
+                <a:cs typeface="Codec Pro"/>
+                <a:sym typeface="Codec Pro"/>
+              </a:rPr>
+              <a:t> de outliers, </a:t>
+            </a:r>
+            <a:r>
+              <a:rPr lang="en-US" sz="2799" u="none" spc="55" dirty="0" err="1">
+                <a:solidFill>
+                  <a:srgbClr val="000000"/>
+                </a:solidFill>
+                <a:latin typeface="Codec Pro"/>
+                <a:ea typeface="Codec Pro"/>
+                <a:cs typeface="Codec Pro"/>
+                <a:sym typeface="Codec Pro"/>
+              </a:rPr>
+              <a:t>duplicados</a:t>
+            </a:r>
+            <a:r>
+              <a:rPr lang="en-US" sz="2799" u="none" spc="55" dirty="0">
+                <a:solidFill>
+                  <a:srgbClr val="000000"/>
+                </a:solidFill>
+                <a:latin typeface="Codec Pro"/>
+                <a:ea typeface="Codec Pro"/>
+                <a:cs typeface="Codec Pro"/>
+                <a:sym typeface="Codec Pro"/>
+              </a:rPr>
+              <a:t>, </a:t>
+            </a:r>
+            <a:r>
+              <a:rPr lang="en-US" sz="2799" u="none" spc="55" dirty="0" err="1">
+                <a:solidFill>
+                  <a:srgbClr val="000000"/>
+                </a:solidFill>
+                <a:latin typeface="Codec Pro"/>
+                <a:ea typeface="Codec Pro"/>
+                <a:cs typeface="Codec Pro"/>
+                <a:sym typeface="Codec Pro"/>
+              </a:rPr>
+              <a:t>diferencias</a:t>
+            </a:r>
+            <a:r>
+              <a:rPr lang="en-US" sz="2799" u="none" spc="55" dirty="0">
+                <a:solidFill>
+                  <a:srgbClr val="000000"/>
+                </a:solidFill>
+                <a:latin typeface="Codec Pro"/>
+                <a:ea typeface="Codec Pro"/>
+                <a:cs typeface="Codec Pro"/>
+                <a:sym typeface="Codec Pro"/>
+              </a:rPr>
+              <a:t> de </a:t>
+            </a:r>
+            <a:r>
+              <a:rPr lang="en-US" sz="2799" u="none" spc="55" dirty="0" err="1">
+                <a:solidFill>
+                  <a:srgbClr val="000000"/>
+                </a:solidFill>
+                <a:latin typeface="Codec Pro"/>
+                <a:ea typeface="Codec Pro"/>
+                <a:cs typeface="Codec Pro"/>
+                <a:sym typeface="Codec Pro"/>
+              </a:rPr>
+              <a:t>formato</a:t>
+            </a:r>
+            <a:r>
+              <a:rPr lang="en-US" sz="2799" u="none" spc="55" dirty="0">
+                <a:solidFill>
+                  <a:srgbClr val="000000"/>
+                </a:solidFill>
+                <a:latin typeface="Codec Pro"/>
+                <a:ea typeface="Codec Pro"/>
+                <a:cs typeface="Codec Pro"/>
+                <a:sym typeface="Codec Pro"/>
+              </a:rPr>
+              <a:t> y </a:t>
+            </a:r>
+            <a:r>
+              <a:rPr lang="en-US" sz="2799" u="none" spc="55" dirty="0" err="1">
+                <a:solidFill>
+                  <a:srgbClr val="000000"/>
+                </a:solidFill>
+                <a:latin typeface="Codec Pro"/>
+                <a:ea typeface="Codec Pro"/>
+                <a:cs typeface="Codec Pro"/>
+                <a:sym typeface="Codec Pro"/>
+              </a:rPr>
+              <a:t>georreferencias</a:t>
+            </a:r>
+            <a:r>
+              <a:rPr lang="en-US" sz="2799" u="none" spc="55" dirty="0">
+                <a:solidFill>
+                  <a:srgbClr val="000000"/>
+                </a:solidFill>
+                <a:latin typeface="Codec Pro"/>
+                <a:ea typeface="Codec Pro"/>
+                <a:cs typeface="Codec Pro"/>
+                <a:sym typeface="Codec Pro"/>
+              </a:rPr>
+              <a:t>.</a:t>
             </a:r>
           </a:p>
           <a:p>
@@ -5350,7 +7070,7 @@
                 <a:spcPts val="3667"/>
               </a:lnSpc>
             </a:pPr>
-            <a:endParaRPr lang="en-US" sz="2799" u="none" spc="55">
+            <a:endParaRPr lang="en-US" sz="2799" u="none" spc="55" dirty="0">
               <a:solidFill>
                 <a:srgbClr val="000000"/>
               </a:solidFill>
@@ -5403,6 +7123,36 @@
           </a:p>
         </p:txBody>
       </p:sp>
+      <p:sp>
+        <p:nvSpPr>
+          <p:cNvPr id="7" name="Marcador de número de diapositiva 6">
+            <a:extLst>
+              <a:ext uri="{FF2B5EF4-FFF2-40B4-BE49-F238E27FC236}">
+                <a16:creationId xmlns:a16="http://schemas.microsoft.com/office/drawing/2014/main" id="{D22855EC-9F0B-96AE-F2E1-1108DF8AD2BE}"/>
+              </a:ext>
+            </a:extLst>
+          </p:cNvPr>
+          <p:cNvSpPr>
+            <a:spLocks noGrp="1"/>
+          </p:cNvSpPr>
+          <p:nvPr>
+            <p:ph type="sldNum" sz="quarter" idx="12"/>
+          </p:nvPr>
+        </p:nvSpPr>
+        <p:spPr/>
+        <p:txBody>
+          <a:bodyPr/>
+          <a:lstStyle/>
+          <a:p>
+            <a:fld id="{B6F15528-21DE-4FAA-801E-634DDDAF4B2B}" type="slidenum">
+              <a:rPr lang="en-US" smtClean="0"/>
+              <a:pPr/>
+              <a:t>3</a:t>
+            </a:fld>
+            <a:endParaRPr lang="en-US"/>
+          </a:p>
+        </p:txBody>
+      </p:sp>
     </p:spTree>
   </p:cSld>
   <p:clrMapOvr>
@@ -5411,7 +7161,7 @@
 </p:sld>
 </file>
 
-<file path=ppt/slides/slide5.xml><?xml version="1.0" encoding="utf-8"?>
+<file path=ppt/slides/slide4.xml><?xml version="1.0" encoding="utf-8"?>
 <p:sld xmlns:a="http://schemas.openxmlformats.org/drawingml/2006/main" xmlns:r="http://schemas.openxmlformats.org/officeDocument/2006/relationships" xmlns:p="http://schemas.openxmlformats.org/presentationml/2006/main">
   <p:cSld>
     <p:spTree>
@@ -5924,6 +7674,36 @@
           </a:p>
         </p:txBody>
       </p:sp>
+      <p:sp>
+        <p:nvSpPr>
+          <p:cNvPr id="7" name="Marcador de número de diapositiva 6">
+            <a:extLst>
+              <a:ext uri="{FF2B5EF4-FFF2-40B4-BE49-F238E27FC236}">
+                <a16:creationId xmlns:a16="http://schemas.microsoft.com/office/drawing/2014/main" id="{D9B2DD55-4652-F457-DA3D-48AA5426013C}"/>
+              </a:ext>
+            </a:extLst>
+          </p:cNvPr>
+          <p:cNvSpPr>
+            <a:spLocks noGrp="1"/>
+          </p:cNvSpPr>
+          <p:nvPr>
+            <p:ph type="sldNum" sz="quarter" idx="12"/>
+          </p:nvPr>
+        </p:nvSpPr>
+        <p:spPr/>
+        <p:txBody>
+          <a:bodyPr/>
+          <a:lstStyle/>
+          <a:p>
+            <a:fld id="{B6F15528-21DE-4FAA-801E-634DDDAF4B2B}" type="slidenum">
+              <a:rPr lang="en-US" smtClean="0"/>
+              <a:pPr/>
+              <a:t>4</a:t>
+            </a:fld>
+            <a:endParaRPr lang="en-US"/>
+          </a:p>
+        </p:txBody>
+      </p:sp>
     </p:spTree>
   </p:cSld>
   <p:clrMapOvr>
@@ -5932,7 +7712,7 @@
 </p:sld>
 </file>
 
-<file path=ppt/slides/slide6.xml><?xml version="1.0" encoding="utf-8"?>
+<file path=ppt/slides/slide5.xml><?xml version="1.0" encoding="utf-8"?>
 <p:sld xmlns:a="http://schemas.openxmlformats.org/drawingml/2006/main" xmlns:r="http://schemas.openxmlformats.org/officeDocument/2006/relationships" xmlns:p="http://schemas.openxmlformats.org/presentationml/2006/main">
   <p:cSld>
     <p:spTree>
@@ -6077,6 +7857,36 @@
               </a:rPr>
               <a:t>RESULTADOS</a:t>
             </a:r>
+          </a:p>
+        </p:txBody>
+      </p:sp>
+      <p:sp>
+        <p:nvSpPr>
+          <p:cNvPr id="6" name="Marcador de número de diapositiva 5">
+            <a:extLst>
+              <a:ext uri="{FF2B5EF4-FFF2-40B4-BE49-F238E27FC236}">
+                <a16:creationId xmlns:a16="http://schemas.microsoft.com/office/drawing/2014/main" id="{CC87CF37-5F02-BC13-1158-BC1EDBFCA41C}"/>
+              </a:ext>
+            </a:extLst>
+          </p:cNvPr>
+          <p:cNvSpPr>
+            <a:spLocks noGrp="1"/>
+          </p:cNvSpPr>
+          <p:nvPr>
+            <p:ph type="sldNum" sz="quarter" idx="12"/>
+          </p:nvPr>
+        </p:nvSpPr>
+        <p:spPr/>
+        <p:txBody>
+          <a:bodyPr/>
+          <a:lstStyle/>
+          <a:p>
+            <a:fld id="{B6F15528-21DE-4FAA-801E-634DDDAF4B2B}" type="slidenum">
+              <a:rPr lang="en-US" smtClean="0"/>
+              <a:pPr/>
+              <a:t>5</a:t>
+            </a:fld>
+            <a:endParaRPr lang="en-US"/>
           </a:p>
         </p:txBody>
       </p:sp>
@@ -6369,4 +8179,319 @@
   <a:objectDefaults/>
   <a:extraClrSchemeLst/>
 </a:theme>
+</file>
+
+<file path=ppt/theme/theme2.xml><?xml version="1.0" encoding="utf-8"?>
+<a:theme xmlns:a="http://schemas.openxmlformats.org/drawingml/2006/main" name="Tema de Office">
+  <a:themeElements>
+    <a:clrScheme name="Office">
+      <a:dk1>
+        <a:sysClr val="windowText" lastClr="000000"/>
+      </a:dk1>
+      <a:lt1>
+        <a:sysClr val="window" lastClr="FFFFFF"/>
+      </a:lt1>
+      <a:dk2>
+        <a:srgbClr val="0E2841"/>
+      </a:dk2>
+      <a:lt2>
+        <a:srgbClr val="E8E8E8"/>
+      </a:lt2>
+      <a:accent1>
+        <a:srgbClr val="156082"/>
+      </a:accent1>
+      <a:accent2>
+        <a:srgbClr val="E97132"/>
+      </a:accent2>
+      <a:accent3>
+        <a:srgbClr val="196B24"/>
+      </a:accent3>
+      <a:accent4>
+        <a:srgbClr val="0F9ED5"/>
+      </a:accent4>
+      <a:accent5>
+        <a:srgbClr val="A02B93"/>
+      </a:accent5>
+      <a:accent6>
+        <a:srgbClr val="4EA72E"/>
+      </a:accent6>
+      <a:hlink>
+        <a:srgbClr val="467886"/>
+      </a:hlink>
+      <a:folHlink>
+        <a:srgbClr val="96607D"/>
+      </a:folHlink>
+    </a:clrScheme>
+    <a:fontScheme name="Office">
+      <a:majorFont>
+        <a:latin typeface="Aptos Display" panose="02110004020202020204"/>
+        <a:ea typeface=""/>
+        <a:cs typeface=""/>
+        <a:font script="Jpan" typeface="游ゴシック Light"/>
+        <a:font script="Hang" typeface="맑은 고딕"/>
+        <a:font script="Hans" typeface="等线 Light"/>
+        <a:font script="Hant" typeface="新細明體"/>
+        <a:font script="Arab" typeface="Times New Roman"/>
+        <a:font script="Hebr" typeface="Times New Roman"/>
+        <a:font script="Thai" typeface="Angsana New"/>
+        <a:font script="Ethi" typeface="Nyala"/>
+        <a:font script="Beng" typeface="Vrinda"/>
+        <a:font script="Gujr" typeface="Shruti"/>
+        <a:font script="Khmr" typeface="MoolBoran"/>
+        <a:font script="Knda" typeface="Tunga"/>
+        <a:font script="Guru" typeface="Raavi"/>
+        <a:font script="Cans" typeface="Euphemia"/>
+        <a:font script="Cher" typeface="Plantagenet Cherokee"/>
+        <a:font script="Yiii" typeface="Microsoft Yi Baiti"/>
+        <a:font script="Tibt" typeface="Microsoft Himalaya"/>
+        <a:font script="Thaa" typeface="MV Boli"/>
+        <a:font script="Deva" typeface="Mangal"/>
+        <a:font script="Telu" typeface="Gautami"/>
+        <a:font script="Taml" typeface="Latha"/>
+        <a:font script="Syrc" typeface="Estrangelo Edessa"/>
+        <a:font script="Orya" typeface="Kalinga"/>
+        <a:font script="Mlym" typeface="Kartika"/>
+        <a:font script="Laoo" typeface="DokChampa"/>
+        <a:font script="Sinh" typeface="Iskoola Pota"/>
+        <a:font script="Mong" typeface="Mongolian Baiti"/>
+        <a:font script="Viet" typeface="Times New Roman"/>
+        <a:font script="Uigh" typeface="Microsoft Uighur"/>
+        <a:font script="Geor" typeface="Sylfaen"/>
+        <a:font script="Armn" typeface="Arial"/>
+        <a:font script="Bugi" typeface="Leelawadee UI"/>
+        <a:font script="Bopo" typeface="Microsoft JhengHei"/>
+        <a:font script="Java" typeface="Javanese Text"/>
+        <a:font script="Lisu" typeface="Segoe UI"/>
+        <a:font script="Mymr" typeface="Myanmar Text"/>
+        <a:font script="Nkoo" typeface="Ebrima"/>
+        <a:font script="Olck" typeface="Nirmala UI"/>
+        <a:font script="Osma" typeface="Ebrima"/>
+        <a:font script="Phag" typeface="Phagspa"/>
+        <a:font script="Syrn" typeface="Estrangelo Edessa"/>
+        <a:font script="Syrj" typeface="Estrangelo Edessa"/>
+        <a:font script="Syre" typeface="Estrangelo Edessa"/>
+        <a:font script="Sora" typeface="Nirmala UI"/>
+        <a:font script="Tale" typeface="Microsoft Tai Le"/>
+        <a:font script="Talu" typeface="Microsoft New Tai Lue"/>
+        <a:font script="Tfng" typeface="Ebrima"/>
+      </a:majorFont>
+      <a:minorFont>
+        <a:latin typeface="Aptos" panose="02110004020202020204"/>
+        <a:ea typeface=""/>
+        <a:cs typeface=""/>
+        <a:font script="Jpan" typeface="游ゴシック"/>
+        <a:font script="Hang" typeface="맑은 고딕"/>
+        <a:font script="Hans" typeface="等线"/>
+        <a:font script="Hant" typeface="新細明體"/>
+        <a:font script="Arab" typeface="Arial"/>
+        <a:font script="Hebr" typeface="Arial"/>
+        <a:font script="Thai" typeface="Cordia New"/>
+        <a:font script="Ethi" typeface="Nyala"/>
+        <a:font script="Beng" typeface="Vrinda"/>
+        <a:font script="Gujr" typeface="Shruti"/>
+        <a:font script="Khmr" typeface="DaunPenh"/>
+        <a:font script="Knda" typeface="Tunga"/>
+        <a:font script="Guru" typeface="Raavi"/>
+        <a:font script="Cans" typeface="Euphemia"/>
+        <a:font script="Cher" typeface="Plantagenet Cherokee"/>
+        <a:font script="Yiii" typeface="Microsoft Yi Baiti"/>
+        <a:font script="Tibt" typeface="Microsoft Himalaya"/>
+        <a:font script="Thaa" typeface="MV Boli"/>
+        <a:font script="Deva" typeface="Mangal"/>
+        <a:font script="Telu" typeface="Gautami"/>
+        <a:font script="Taml" typeface="Latha"/>
+        <a:font script="Syrc" typeface="Estrangelo Edessa"/>
+        <a:font script="Orya" typeface="Kalinga"/>
+        <a:font script="Mlym" typeface="Kartika"/>
+        <a:font script="Laoo" typeface="DokChampa"/>
+        <a:font script="Sinh" typeface="Iskoola Pota"/>
+        <a:font script="Mong" typeface="Mongolian Baiti"/>
+        <a:font script="Viet" typeface="Arial"/>
+        <a:font script="Uigh" typeface="Microsoft Uighur"/>
+        <a:font script="Geor" typeface="Sylfaen"/>
+        <a:font script="Armn" typeface="Arial"/>
+        <a:font script="Bugi" typeface="Leelawadee UI"/>
+        <a:font script="Bopo" typeface="Microsoft JhengHei"/>
+        <a:font script="Java" typeface="Javanese Text"/>
+        <a:font script="Lisu" typeface="Segoe UI"/>
+        <a:font script="Mymr" typeface="Myanmar Text"/>
+        <a:font script="Nkoo" typeface="Ebrima"/>
+        <a:font script="Olck" typeface="Nirmala UI"/>
+        <a:font script="Osma" typeface="Ebrima"/>
+        <a:font script="Phag" typeface="Phagspa"/>
+        <a:font script="Syrn" typeface="Estrangelo Edessa"/>
+        <a:font script="Syrj" typeface="Estrangelo Edessa"/>
+        <a:font script="Syre" typeface="Estrangelo Edessa"/>
+        <a:font script="Sora" typeface="Nirmala UI"/>
+        <a:font script="Tale" typeface="Microsoft Tai Le"/>
+        <a:font script="Talu" typeface="Microsoft New Tai Lue"/>
+        <a:font script="Tfng" typeface="Ebrima"/>
+      </a:minorFont>
+    </a:fontScheme>
+    <a:fmtScheme name="Office">
+      <a:fillStyleLst>
+        <a:solidFill>
+          <a:schemeClr val="phClr"/>
+        </a:solidFill>
+        <a:gradFill rotWithShape="1">
+          <a:gsLst>
+            <a:gs pos="0">
+              <a:schemeClr val="phClr">
+                <a:lumMod val="110000"/>
+                <a:satMod val="105000"/>
+                <a:tint val="67000"/>
+              </a:schemeClr>
+            </a:gs>
+            <a:gs pos="50000">
+              <a:schemeClr val="phClr">
+                <a:lumMod val="105000"/>
+                <a:satMod val="103000"/>
+                <a:tint val="73000"/>
+              </a:schemeClr>
+            </a:gs>
+            <a:gs pos="100000">
+              <a:schemeClr val="phClr">
+                <a:lumMod val="105000"/>
+                <a:satMod val="109000"/>
+                <a:tint val="81000"/>
+              </a:schemeClr>
+            </a:gs>
+          </a:gsLst>
+          <a:lin ang="5400000" scaled="0"/>
+        </a:gradFill>
+        <a:gradFill rotWithShape="1">
+          <a:gsLst>
+            <a:gs pos="0">
+              <a:schemeClr val="phClr">
+                <a:satMod val="103000"/>
+                <a:lumMod val="102000"/>
+                <a:tint val="94000"/>
+              </a:schemeClr>
+            </a:gs>
+            <a:gs pos="50000">
+              <a:schemeClr val="phClr">
+                <a:satMod val="110000"/>
+                <a:lumMod val="100000"/>
+                <a:shade val="100000"/>
+              </a:schemeClr>
+            </a:gs>
+            <a:gs pos="100000">
+              <a:schemeClr val="phClr">
+                <a:lumMod val="99000"/>
+                <a:satMod val="120000"/>
+                <a:shade val="78000"/>
+              </a:schemeClr>
+            </a:gs>
+          </a:gsLst>
+          <a:lin ang="5400000" scaled="0"/>
+        </a:gradFill>
+      </a:fillStyleLst>
+      <a:lnStyleLst>
+        <a:ln w="12700" cap="flat" cmpd="sng" algn="ctr">
+          <a:solidFill>
+            <a:schemeClr val="phClr"/>
+          </a:solidFill>
+          <a:prstDash val="solid"/>
+          <a:miter lim="800000"/>
+        </a:ln>
+        <a:ln w="19050" cap="flat" cmpd="sng" algn="ctr">
+          <a:solidFill>
+            <a:schemeClr val="phClr"/>
+          </a:solidFill>
+          <a:prstDash val="solid"/>
+          <a:miter lim="800000"/>
+        </a:ln>
+        <a:ln w="25400" cap="flat" cmpd="sng" algn="ctr">
+          <a:solidFill>
+            <a:schemeClr val="phClr"/>
+          </a:solidFill>
+          <a:prstDash val="solid"/>
+          <a:miter lim="800000"/>
+        </a:ln>
+      </a:lnStyleLst>
+      <a:effectStyleLst>
+        <a:effectStyle>
+          <a:effectLst/>
+        </a:effectStyle>
+        <a:effectStyle>
+          <a:effectLst/>
+        </a:effectStyle>
+        <a:effectStyle>
+          <a:effectLst>
+            <a:outerShdw blurRad="57150" dist="19050" dir="5400000" algn="ctr" rotWithShape="0">
+              <a:srgbClr val="000000">
+                <a:alpha val="63000"/>
+              </a:srgbClr>
+            </a:outerShdw>
+          </a:effectLst>
+        </a:effectStyle>
+      </a:effectStyleLst>
+      <a:bgFillStyleLst>
+        <a:solidFill>
+          <a:schemeClr val="phClr"/>
+        </a:solidFill>
+        <a:solidFill>
+          <a:schemeClr val="phClr">
+            <a:tint val="95000"/>
+            <a:satMod val="170000"/>
+          </a:schemeClr>
+        </a:solidFill>
+        <a:gradFill rotWithShape="1">
+          <a:gsLst>
+            <a:gs pos="0">
+              <a:schemeClr val="phClr">
+                <a:tint val="93000"/>
+                <a:satMod val="150000"/>
+                <a:shade val="98000"/>
+                <a:lumMod val="102000"/>
+              </a:schemeClr>
+            </a:gs>
+            <a:gs pos="50000">
+              <a:schemeClr val="phClr">
+                <a:tint val="98000"/>
+                <a:satMod val="130000"/>
+                <a:shade val="90000"/>
+                <a:lumMod val="103000"/>
+              </a:schemeClr>
+            </a:gs>
+            <a:gs pos="100000">
+              <a:schemeClr val="phClr">
+                <a:shade val="63000"/>
+                <a:satMod val="120000"/>
+              </a:schemeClr>
+            </a:gs>
+          </a:gsLst>
+          <a:lin ang="5400000" scaled="0"/>
+        </a:gradFill>
+      </a:bgFillStyleLst>
+    </a:fmtScheme>
+  </a:themeElements>
+  <a:objectDefaults>
+    <a:lnDef>
+      <a:spPr/>
+      <a:bodyPr/>
+      <a:lstStyle/>
+      <a:style>
+        <a:lnRef idx="2">
+          <a:schemeClr val="accent1"/>
+        </a:lnRef>
+        <a:fillRef idx="0">
+          <a:schemeClr val="accent1"/>
+        </a:fillRef>
+        <a:effectRef idx="1">
+          <a:schemeClr val="accent1"/>
+        </a:effectRef>
+        <a:fontRef idx="minor">
+          <a:schemeClr val="tx1"/>
+        </a:fontRef>
+      </a:style>
+    </a:lnDef>
+  </a:objectDefaults>
+  <a:extraClrSchemeLst/>
+  <a:extLst>
+    <a:ext uri="{05A4C25C-085E-4340-85A3-A5531E510DB2}">
+      <thm15:themeFamily xmlns:thm15="http://schemas.microsoft.com/office/thememl/2012/main" name="Office Theme" id="{2E142A2C-CD16-42D6-873A-C26D2A0506FA}" vid="{1BDDFF52-6CD6-40A5-AB3C-68EB2F1E4D0A}"/>
+    </a:ext>
+  </a:extLst>
+</a:theme>
 </file>
</xml_diff>